<commit_message>
Make the education icons more contrasting
</commit_message>
<xml_diff>
--- a/Icons/Icon Dev.pptx
+++ b/Icons/Icon Dev.pptx
@@ -6,6 +6,7 @@
   </p:sldMasterIdLst>
   <p:sldIdLst>
     <p:sldId id="256" r:id="rId2"/>
+    <p:sldId id="257" r:id="rId3"/>
   </p:sldIdLst>
   <p:sldSz cx="12192000" cy="6858000"/>
   <p:notesSz cx="6858000" cy="9144000"/>
@@ -104,6 +105,11 @@
       </a:defRPr>
     </a:lvl9pPr>
   </p:defaultTextStyle>
+  <p:extLst>
+    <p:ext uri="{EFAFB233-063F-42B5-8137-9DF3F51BA10A}">
+      <p15:sldGuideLst xmlns:p15="http://schemas.microsoft.com/office/powerpoint/2012/main"/>
+    </p:ext>
+  </p:extLst>
 </p:presentation>
 </file>
 
@@ -256,7 +262,7 @@
           <a:p>
             <a:fld id="{435D7AEF-48A4-4CF2-A209-6A6A62757181}" type="datetimeFigureOut">
               <a:rPr lang="en-GB" smtClean="0"/>
-              <a:t>28/09/2026</a:t>
+              <a:t>29/10/2026</a:t>
             </a:fld>
             <a:endParaRPr lang="en-GB"/>
           </a:p>
@@ -456,7 +462,7 @@
           <a:p>
             <a:fld id="{435D7AEF-48A4-4CF2-A209-6A6A62757181}" type="datetimeFigureOut">
               <a:rPr lang="en-GB" smtClean="0"/>
-              <a:t>28/09/2026</a:t>
+              <a:t>29/10/2026</a:t>
             </a:fld>
             <a:endParaRPr lang="en-GB"/>
           </a:p>
@@ -666,7 +672,7 @@
           <a:p>
             <a:fld id="{435D7AEF-48A4-4CF2-A209-6A6A62757181}" type="datetimeFigureOut">
               <a:rPr lang="en-GB" smtClean="0"/>
-              <a:t>28/09/2026</a:t>
+              <a:t>29/10/2026</a:t>
             </a:fld>
             <a:endParaRPr lang="en-GB"/>
           </a:p>
@@ -866,7 +872,7 @@
           <a:p>
             <a:fld id="{435D7AEF-48A4-4CF2-A209-6A6A62757181}" type="datetimeFigureOut">
               <a:rPr lang="en-GB" smtClean="0"/>
-              <a:t>28/09/2026</a:t>
+              <a:t>29/10/2026</a:t>
             </a:fld>
             <a:endParaRPr lang="en-GB"/>
           </a:p>
@@ -1142,7 +1148,7 @@
           <a:p>
             <a:fld id="{435D7AEF-48A4-4CF2-A209-6A6A62757181}" type="datetimeFigureOut">
               <a:rPr lang="en-GB" smtClean="0"/>
-              <a:t>28/09/2026</a:t>
+              <a:t>29/10/2026</a:t>
             </a:fld>
             <a:endParaRPr lang="en-GB"/>
           </a:p>
@@ -1410,7 +1416,7 @@
           <a:p>
             <a:fld id="{435D7AEF-48A4-4CF2-A209-6A6A62757181}" type="datetimeFigureOut">
               <a:rPr lang="en-GB" smtClean="0"/>
-              <a:t>28/09/2026</a:t>
+              <a:t>29/10/2026</a:t>
             </a:fld>
             <a:endParaRPr lang="en-GB"/>
           </a:p>
@@ -1825,7 +1831,7 @@
           <a:p>
             <a:fld id="{435D7AEF-48A4-4CF2-A209-6A6A62757181}" type="datetimeFigureOut">
               <a:rPr lang="en-GB" smtClean="0"/>
-              <a:t>28/09/2026</a:t>
+              <a:t>29/10/2026</a:t>
             </a:fld>
             <a:endParaRPr lang="en-GB"/>
           </a:p>
@@ -1967,7 +1973,7 @@
           <a:p>
             <a:fld id="{435D7AEF-48A4-4CF2-A209-6A6A62757181}" type="datetimeFigureOut">
               <a:rPr lang="en-GB" smtClean="0"/>
-              <a:t>28/09/2026</a:t>
+              <a:t>29/10/2026</a:t>
             </a:fld>
             <a:endParaRPr lang="en-GB"/>
           </a:p>
@@ -2080,7 +2086,7 @@
           <a:p>
             <a:fld id="{435D7AEF-48A4-4CF2-A209-6A6A62757181}" type="datetimeFigureOut">
               <a:rPr lang="en-GB" smtClean="0"/>
-              <a:t>28/09/2026</a:t>
+              <a:t>29/10/2026</a:t>
             </a:fld>
             <a:endParaRPr lang="en-GB"/>
           </a:p>
@@ -2393,7 +2399,7 @@
           <a:p>
             <a:fld id="{435D7AEF-48A4-4CF2-A209-6A6A62757181}" type="datetimeFigureOut">
               <a:rPr lang="en-GB" smtClean="0"/>
-              <a:t>28/09/2026</a:t>
+              <a:t>29/10/2026</a:t>
             </a:fld>
             <a:endParaRPr lang="en-GB"/>
           </a:p>
@@ -2682,7 +2688,7 @@
           <a:p>
             <a:fld id="{435D7AEF-48A4-4CF2-A209-6A6A62757181}" type="datetimeFigureOut">
               <a:rPr lang="en-GB" smtClean="0"/>
-              <a:t>28/09/2026</a:t>
+              <a:t>29/10/2026</a:t>
             </a:fld>
             <a:endParaRPr lang="en-GB"/>
           </a:p>
@@ -2925,7 +2931,7 @@
           <a:p>
             <a:fld id="{435D7AEF-48A4-4CF2-A209-6A6A62757181}" type="datetimeFigureOut">
               <a:rPr lang="en-GB" smtClean="0"/>
-              <a:t>28/09/2026</a:t>
+              <a:t>29/10/2026</a:t>
             </a:fld>
             <a:endParaRPr lang="en-GB"/>
           </a:p>
@@ -4205,6 +4211,2796 @@
 </p:sld>
 </file>
 
+<file path=ppt/slides/slide2.xml><?xml version="1.0" encoding="utf-8"?>
+<p:sld xmlns:a="http://schemas.openxmlformats.org/drawingml/2006/main" xmlns:r="http://schemas.openxmlformats.org/officeDocument/2006/relationships" xmlns:p="http://schemas.openxmlformats.org/presentationml/2006/main">
+  <p:cSld>
+    <p:spTree>
+      <p:nvGrpSpPr>
+        <p:cNvPr id="1" name=""/>
+        <p:cNvGrpSpPr/>
+        <p:nvPr/>
+      </p:nvGrpSpPr>
+      <p:grpSpPr>
+        <a:xfrm>
+          <a:off x="0" y="0"/>
+          <a:ext cx="0" cy="0"/>
+          <a:chOff x="0" y="0"/>
+          <a:chExt cx="0" cy="0"/>
+        </a:xfrm>
+      </p:grpSpPr>
+      <p:pic>
+        <p:nvPicPr>
+          <p:cNvPr id="173" name="Picture 172" descr="Sad Woman Icon in SVG, PNG formats">
+            <a:extLst>
+              <a:ext uri="{FF2B5EF4-FFF2-40B4-BE49-F238E27FC236}">
+                <a16:creationId xmlns:a16="http://schemas.microsoft.com/office/drawing/2014/main" id="{0E68A86A-7027-DFAF-46E8-A9F87E3B21E7}"/>
+              </a:ext>
+            </a:extLst>
+          </p:cNvPr>
+          <p:cNvPicPr>
+            <a:picLocks noChangeAspect="1"/>
+          </p:cNvPicPr>
+          <p:nvPr/>
+        </p:nvPicPr>
+        <p:blipFill>
+          <a:blip r:embed="rId2">
+            <a:lum bright="70000" contrast="-70000"/>
+          </a:blip>
+          <a:stretch>
+            <a:fillRect/>
+          </a:stretch>
+        </p:blipFill>
+        <p:spPr>
+          <a:xfrm>
+            <a:off x="10622792" y="1393901"/>
+            <a:ext cx="604757" cy="604757"/>
+          </a:xfrm>
+          <a:prstGeom prst="rect">
+            <a:avLst/>
+          </a:prstGeom>
+        </p:spPr>
+      </p:pic>
+      <p:pic>
+        <p:nvPicPr>
+          <p:cNvPr id="175" name="Picture 174">
+            <a:extLst>
+              <a:ext uri="{FF2B5EF4-FFF2-40B4-BE49-F238E27FC236}">
+                <a16:creationId xmlns:a16="http://schemas.microsoft.com/office/drawing/2014/main" id="{B3C9FA9B-A0DF-FE93-CC1D-17187EFCC47F}"/>
+              </a:ext>
+            </a:extLst>
+          </p:cNvPr>
+          <p:cNvPicPr>
+            <a:picLocks noChangeAspect="1"/>
+          </p:cNvPicPr>
+          <p:nvPr/>
+        </p:nvPicPr>
+        <p:blipFill>
+          <a:blip r:embed="rId3">
+            <a:lum bright="70000" contrast="-70000"/>
+          </a:blip>
+          <a:stretch>
+            <a:fillRect/>
+          </a:stretch>
+        </p:blipFill>
+        <p:spPr>
+          <a:xfrm>
+            <a:off x="11123184" y="1394491"/>
+            <a:ext cx="604167" cy="604167"/>
+          </a:xfrm>
+          <a:prstGeom prst="rect">
+            <a:avLst/>
+          </a:prstGeom>
+        </p:spPr>
+      </p:pic>
+      <p:pic>
+        <p:nvPicPr>
+          <p:cNvPr id="177" name="Picture 176" descr="Sad Woman Icon in SVG, PNG formats">
+            <a:extLst>
+              <a:ext uri="{FF2B5EF4-FFF2-40B4-BE49-F238E27FC236}">
+                <a16:creationId xmlns:a16="http://schemas.microsoft.com/office/drawing/2014/main" id="{23F3D7F8-4F73-03AA-F53C-DCDE3F297992}"/>
+              </a:ext>
+            </a:extLst>
+          </p:cNvPr>
+          <p:cNvPicPr>
+            <a:picLocks noChangeAspect="1"/>
+          </p:cNvPicPr>
+          <p:nvPr/>
+        </p:nvPicPr>
+        <p:blipFill>
+          <a:blip r:embed="rId2">
+            <a:lum bright="70000" contrast="-70000"/>
+          </a:blip>
+          <a:stretch>
+            <a:fillRect/>
+          </a:stretch>
+        </p:blipFill>
+        <p:spPr>
+          <a:xfrm>
+            <a:off x="10838608" y="789145"/>
+            <a:ext cx="604757" cy="604757"/>
+          </a:xfrm>
+          <a:prstGeom prst="rect">
+            <a:avLst/>
+          </a:prstGeom>
+        </p:spPr>
+      </p:pic>
+      <p:pic>
+        <p:nvPicPr>
+          <p:cNvPr id="189" name="Picture 188">
+            <a:extLst>
+              <a:ext uri="{FF2B5EF4-FFF2-40B4-BE49-F238E27FC236}">
+                <a16:creationId xmlns:a16="http://schemas.microsoft.com/office/drawing/2014/main" id="{16663AE8-7086-B0D4-46F4-82D0E122458B}"/>
+              </a:ext>
+            </a:extLst>
+          </p:cNvPr>
+          <p:cNvPicPr>
+            <a:picLocks noChangeAspect="1"/>
+          </p:cNvPicPr>
+          <p:nvPr/>
+        </p:nvPicPr>
+        <p:blipFill>
+          <a:blip r:embed="rId3">
+            <a:lum bright="70000" contrast="-70000"/>
+          </a:blip>
+          <a:stretch>
+            <a:fillRect/>
+          </a:stretch>
+        </p:blipFill>
+        <p:spPr>
+          <a:xfrm>
+            <a:off x="10461143" y="2011026"/>
+            <a:ext cx="604167" cy="604167"/>
+          </a:xfrm>
+          <a:prstGeom prst="rect">
+            <a:avLst/>
+          </a:prstGeom>
+        </p:spPr>
+      </p:pic>
+      <p:pic>
+        <p:nvPicPr>
+          <p:cNvPr id="191" name="Picture 190" descr="Sad Woman Icon in SVG, PNG formats">
+            <a:extLst>
+              <a:ext uri="{FF2B5EF4-FFF2-40B4-BE49-F238E27FC236}">
+                <a16:creationId xmlns:a16="http://schemas.microsoft.com/office/drawing/2014/main" id="{856E9E29-2D2C-A829-D12A-93CD31C5534B}"/>
+              </a:ext>
+            </a:extLst>
+          </p:cNvPr>
+          <p:cNvPicPr>
+            <a:picLocks noChangeAspect="1"/>
+          </p:cNvPicPr>
+          <p:nvPr/>
+        </p:nvPicPr>
+        <p:blipFill>
+          <a:blip r:embed="rId2">
+            <a:lum bright="70000" contrast="-70000"/>
+          </a:blip>
+          <a:stretch>
+            <a:fillRect/>
+          </a:stretch>
+        </p:blipFill>
+        <p:spPr>
+          <a:xfrm>
+            <a:off x="10925232" y="2011025"/>
+            <a:ext cx="604757" cy="604757"/>
+          </a:xfrm>
+          <a:prstGeom prst="rect">
+            <a:avLst/>
+          </a:prstGeom>
+        </p:spPr>
+      </p:pic>
+      <p:pic>
+        <p:nvPicPr>
+          <p:cNvPr id="193" name="Picture 192">
+            <a:extLst>
+              <a:ext uri="{FF2B5EF4-FFF2-40B4-BE49-F238E27FC236}">
+                <a16:creationId xmlns:a16="http://schemas.microsoft.com/office/drawing/2014/main" id="{35D7BB0D-E895-9507-1F0C-6E7C3ABDA840}"/>
+              </a:ext>
+            </a:extLst>
+          </p:cNvPr>
+          <p:cNvPicPr>
+            <a:picLocks noChangeAspect="1"/>
+          </p:cNvPicPr>
+          <p:nvPr/>
+        </p:nvPicPr>
+        <p:blipFill>
+          <a:blip r:embed="rId3">
+            <a:lum bright="70000" contrast="-70000"/>
+          </a:blip>
+          <a:stretch>
+            <a:fillRect/>
+          </a:stretch>
+        </p:blipFill>
+        <p:spPr>
+          <a:xfrm>
+            <a:off x="9776858" y="2602148"/>
+            <a:ext cx="604167" cy="604167"/>
+          </a:xfrm>
+          <a:prstGeom prst="rect">
+            <a:avLst/>
+          </a:prstGeom>
+        </p:spPr>
+      </p:pic>
+      <p:pic>
+        <p:nvPicPr>
+          <p:cNvPr id="195" name="Picture 194" descr="Sad Woman Icon in SVG, PNG formats">
+            <a:extLst>
+              <a:ext uri="{FF2B5EF4-FFF2-40B4-BE49-F238E27FC236}">
+                <a16:creationId xmlns:a16="http://schemas.microsoft.com/office/drawing/2014/main" id="{83FCE9FA-F62C-A5BA-2E7C-1D829EE5FE4C}"/>
+              </a:ext>
+            </a:extLst>
+          </p:cNvPr>
+          <p:cNvPicPr>
+            <a:picLocks noChangeAspect="1"/>
+          </p:cNvPicPr>
+          <p:nvPr/>
+        </p:nvPicPr>
+        <p:blipFill>
+          <a:blip r:embed="rId2">
+            <a:lum bright="70000" contrast="-70000"/>
+          </a:blip>
+          <a:stretch>
+            <a:fillRect/>
+          </a:stretch>
+        </p:blipFill>
+        <p:spPr>
+          <a:xfrm>
+            <a:off x="10240742" y="2615783"/>
+            <a:ext cx="604757" cy="604757"/>
+          </a:xfrm>
+          <a:prstGeom prst="rect">
+            <a:avLst/>
+          </a:prstGeom>
+        </p:spPr>
+      </p:pic>
+      <p:pic>
+        <p:nvPicPr>
+          <p:cNvPr id="197" name="Picture 196">
+            <a:extLst>
+              <a:ext uri="{FF2B5EF4-FFF2-40B4-BE49-F238E27FC236}">
+                <a16:creationId xmlns:a16="http://schemas.microsoft.com/office/drawing/2014/main" id="{E3702D7E-A2E7-3C34-3EFC-D1722663ED72}"/>
+              </a:ext>
+            </a:extLst>
+          </p:cNvPr>
+          <p:cNvPicPr>
+            <a:picLocks noChangeAspect="1"/>
+          </p:cNvPicPr>
+          <p:nvPr/>
+        </p:nvPicPr>
+        <p:blipFill>
+          <a:blip r:embed="rId3">
+            <a:lum bright="70000" contrast="-70000"/>
+          </a:blip>
+          <a:stretch>
+            <a:fillRect/>
+          </a:stretch>
+        </p:blipFill>
+        <p:spPr>
+          <a:xfrm>
+            <a:off x="10700826" y="2616373"/>
+            <a:ext cx="604167" cy="604167"/>
+          </a:xfrm>
+          <a:prstGeom prst="rect">
+            <a:avLst/>
+          </a:prstGeom>
+        </p:spPr>
+      </p:pic>
+      <p:pic>
+        <p:nvPicPr>
+          <p:cNvPr id="179" name="Picture 178">
+            <a:extLst>
+              <a:ext uri="{FF2B5EF4-FFF2-40B4-BE49-F238E27FC236}">
+                <a16:creationId xmlns:a16="http://schemas.microsoft.com/office/drawing/2014/main" id="{2F12942C-71F3-C09C-2BEE-F76EA34ED36A}"/>
+              </a:ext>
+            </a:extLst>
+          </p:cNvPr>
+          <p:cNvPicPr>
+            <a:picLocks noChangeAspect="1"/>
+          </p:cNvPicPr>
+          <p:nvPr/>
+        </p:nvPicPr>
+        <p:blipFill>
+          <a:blip r:embed="rId3">
+            <a:lum bright="70000" contrast="-70000"/>
+          </a:blip>
+          <a:stretch>
+            <a:fillRect/>
+          </a:stretch>
+        </p:blipFill>
+        <p:spPr>
+          <a:xfrm>
+            <a:off x="6549599" y="1998659"/>
+            <a:ext cx="604167" cy="604167"/>
+          </a:xfrm>
+          <a:prstGeom prst="rect">
+            <a:avLst/>
+          </a:prstGeom>
+        </p:spPr>
+      </p:pic>
+      <p:pic>
+        <p:nvPicPr>
+          <p:cNvPr id="181" name="Picture 180" descr="Sad Woman Icon in SVG, PNG formats">
+            <a:extLst>
+              <a:ext uri="{FF2B5EF4-FFF2-40B4-BE49-F238E27FC236}">
+                <a16:creationId xmlns:a16="http://schemas.microsoft.com/office/drawing/2014/main" id="{F1C05079-64C8-C316-F12B-4DB978E6D81B}"/>
+              </a:ext>
+            </a:extLst>
+          </p:cNvPr>
+          <p:cNvPicPr>
+            <a:picLocks noChangeAspect="1"/>
+          </p:cNvPicPr>
+          <p:nvPr/>
+        </p:nvPicPr>
+        <p:blipFill>
+          <a:blip r:embed="rId2">
+            <a:lum bright="70000" contrast="-70000"/>
+          </a:blip>
+          <a:stretch>
+            <a:fillRect/>
+          </a:stretch>
+        </p:blipFill>
+        <p:spPr>
+          <a:xfrm>
+            <a:off x="7013688" y="1998658"/>
+            <a:ext cx="604757" cy="604757"/>
+          </a:xfrm>
+          <a:prstGeom prst="rect">
+            <a:avLst/>
+          </a:prstGeom>
+        </p:spPr>
+      </p:pic>
+      <p:pic>
+        <p:nvPicPr>
+          <p:cNvPr id="183" name="Picture 182">
+            <a:extLst>
+              <a:ext uri="{FF2B5EF4-FFF2-40B4-BE49-F238E27FC236}">
+                <a16:creationId xmlns:a16="http://schemas.microsoft.com/office/drawing/2014/main" id="{EEEE2E89-9CE6-DA11-5946-064FF6DD9207}"/>
+              </a:ext>
+            </a:extLst>
+          </p:cNvPr>
+          <p:cNvPicPr>
+            <a:picLocks noChangeAspect="1"/>
+          </p:cNvPicPr>
+          <p:nvPr/>
+        </p:nvPicPr>
+        <p:blipFill>
+          <a:blip r:embed="rId3">
+            <a:lum bright="70000" contrast="-70000"/>
+          </a:blip>
+          <a:stretch>
+            <a:fillRect/>
+          </a:stretch>
+        </p:blipFill>
+        <p:spPr>
+          <a:xfrm>
+            <a:off x="5865314" y="2589781"/>
+            <a:ext cx="604167" cy="604167"/>
+          </a:xfrm>
+          <a:prstGeom prst="rect">
+            <a:avLst/>
+          </a:prstGeom>
+        </p:spPr>
+      </p:pic>
+      <p:pic>
+        <p:nvPicPr>
+          <p:cNvPr id="185" name="Picture 184" descr="Sad Woman Icon in SVG, PNG formats">
+            <a:extLst>
+              <a:ext uri="{FF2B5EF4-FFF2-40B4-BE49-F238E27FC236}">
+                <a16:creationId xmlns:a16="http://schemas.microsoft.com/office/drawing/2014/main" id="{B4096DD6-B52E-59B5-C93D-67B303089E5E}"/>
+              </a:ext>
+            </a:extLst>
+          </p:cNvPr>
+          <p:cNvPicPr>
+            <a:picLocks noChangeAspect="1"/>
+          </p:cNvPicPr>
+          <p:nvPr/>
+        </p:nvPicPr>
+        <p:blipFill>
+          <a:blip r:embed="rId2">
+            <a:lum bright="70000" contrast="-70000"/>
+          </a:blip>
+          <a:stretch>
+            <a:fillRect/>
+          </a:stretch>
+        </p:blipFill>
+        <p:spPr>
+          <a:xfrm>
+            <a:off x="6329198" y="2603416"/>
+            <a:ext cx="604757" cy="604757"/>
+          </a:xfrm>
+          <a:prstGeom prst="rect">
+            <a:avLst/>
+          </a:prstGeom>
+        </p:spPr>
+      </p:pic>
+      <p:pic>
+        <p:nvPicPr>
+          <p:cNvPr id="187" name="Picture 186">
+            <a:extLst>
+              <a:ext uri="{FF2B5EF4-FFF2-40B4-BE49-F238E27FC236}">
+                <a16:creationId xmlns:a16="http://schemas.microsoft.com/office/drawing/2014/main" id="{5FD4568F-199E-D65B-4613-2AA4252E4603}"/>
+              </a:ext>
+            </a:extLst>
+          </p:cNvPr>
+          <p:cNvPicPr>
+            <a:picLocks noChangeAspect="1"/>
+          </p:cNvPicPr>
+          <p:nvPr/>
+        </p:nvPicPr>
+        <p:blipFill>
+          <a:blip r:embed="rId3">
+            <a:lum bright="70000" contrast="-70000"/>
+          </a:blip>
+          <a:stretch>
+            <a:fillRect/>
+          </a:stretch>
+        </p:blipFill>
+        <p:spPr>
+          <a:xfrm>
+            <a:off x="6789282" y="2604006"/>
+            <a:ext cx="604167" cy="604167"/>
+          </a:xfrm>
+          <a:prstGeom prst="rect">
+            <a:avLst/>
+          </a:prstGeom>
+        </p:spPr>
+      </p:pic>
+      <p:pic>
+        <p:nvPicPr>
+          <p:cNvPr id="7" name="Picture 6" descr="Sad Woman Icon in SVG, PNG formats">
+            <a:extLst>
+              <a:ext uri="{FF2B5EF4-FFF2-40B4-BE49-F238E27FC236}">
+                <a16:creationId xmlns:a16="http://schemas.microsoft.com/office/drawing/2014/main" id="{E0370DEA-7510-43E9-1984-90B3660A748B}"/>
+              </a:ext>
+            </a:extLst>
+          </p:cNvPr>
+          <p:cNvPicPr>
+            <a:picLocks noChangeAspect="1"/>
+          </p:cNvPicPr>
+          <p:nvPr/>
+        </p:nvPicPr>
+        <p:blipFill>
+          <a:blip r:embed="rId2">
+            <a:lum bright="70000" contrast="-70000"/>
+          </a:blip>
+          <a:stretch>
+            <a:fillRect/>
+          </a:stretch>
+        </p:blipFill>
+        <p:spPr>
+          <a:xfrm>
+            <a:off x="10021439" y="1985023"/>
+            <a:ext cx="604757" cy="604757"/>
+          </a:xfrm>
+          <a:prstGeom prst="rect">
+            <a:avLst/>
+          </a:prstGeom>
+        </p:spPr>
+      </p:pic>
+      <p:pic>
+        <p:nvPicPr>
+          <p:cNvPr id="9" name="Picture 8">
+            <a:extLst>
+              <a:ext uri="{FF2B5EF4-FFF2-40B4-BE49-F238E27FC236}">
+                <a16:creationId xmlns:a16="http://schemas.microsoft.com/office/drawing/2014/main" id="{EAF18742-C545-E700-48D9-D4C145189C1F}"/>
+              </a:ext>
+            </a:extLst>
+          </p:cNvPr>
+          <p:cNvPicPr>
+            <a:picLocks noChangeAspect="1"/>
+          </p:cNvPicPr>
+          <p:nvPr/>
+        </p:nvPicPr>
+        <p:blipFill>
+          <a:blip r:embed="rId3">
+            <a:lum bright="70000" contrast="-70000"/>
+          </a:blip>
+          <a:stretch>
+            <a:fillRect/>
+          </a:stretch>
+        </p:blipFill>
+        <p:spPr>
+          <a:xfrm>
+            <a:off x="10148885" y="1408127"/>
+            <a:ext cx="604167" cy="604167"/>
+          </a:xfrm>
+          <a:prstGeom prst="rect">
+            <a:avLst/>
+          </a:prstGeom>
+        </p:spPr>
+      </p:pic>
+      <p:pic>
+        <p:nvPicPr>
+          <p:cNvPr id="11" name="Picture 10" descr="Happy Laugh Woman Icon in SVG, PNG formats">
+            <a:extLst>
+              <a:ext uri="{FF2B5EF4-FFF2-40B4-BE49-F238E27FC236}">
+                <a16:creationId xmlns:a16="http://schemas.microsoft.com/office/drawing/2014/main" id="{078330A7-2268-4794-EF00-19E7692203F1}"/>
+              </a:ext>
+            </a:extLst>
+          </p:cNvPr>
+          <p:cNvPicPr>
+            <a:picLocks noChangeAspect="1"/>
+          </p:cNvPicPr>
+          <p:nvPr/>
+        </p:nvPicPr>
+        <p:blipFill>
+          <a:blip r:embed="rId4">
+            <a:duotone>
+              <a:schemeClr val="accent1">
+                <a:shade val="45000"/>
+                <a:satMod val="135000"/>
+              </a:schemeClr>
+              <a:prstClr val="white"/>
+            </a:duotone>
+          </a:blip>
+          <a:stretch>
+            <a:fillRect/>
+          </a:stretch>
+        </p:blipFill>
+        <p:spPr>
+          <a:xfrm>
+            <a:off x="1241585" y="775510"/>
+            <a:ext cx="604757" cy="604757"/>
+          </a:xfrm>
+          <a:prstGeom prst="rect">
+            <a:avLst/>
+          </a:prstGeom>
+        </p:spPr>
+      </p:pic>
+      <p:pic>
+        <p:nvPicPr>
+          <p:cNvPr id="13" name="Picture 12">
+            <a:extLst>
+              <a:ext uri="{FF2B5EF4-FFF2-40B4-BE49-F238E27FC236}">
+                <a16:creationId xmlns:a16="http://schemas.microsoft.com/office/drawing/2014/main" id="{6D9E744C-407C-9589-A29C-117A5CF23038}"/>
+              </a:ext>
+            </a:extLst>
+          </p:cNvPr>
+          <p:cNvPicPr>
+            <a:picLocks noChangeAspect="1"/>
+          </p:cNvPicPr>
+          <p:nvPr/>
+        </p:nvPicPr>
+        <p:blipFill>
+          <a:blip r:embed="rId5">
+            <a:duotone>
+              <a:schemeClr val="accent1">
+                <a:shade val="45000"/>
+                <a:satMod val="135000"/>
+              </a:schemeClr>
+              <a:prstClr val="white"/>
+            </a:duotone>
+          </a:blip>
+          <a:stretch>
+            <a:fillRect/>
+          </a:stretch>
+        </p:blipFill>
+        <p:spPr>
+          <a:xfrm>
+            <a:off x="1712637" y="775510"/>
+            <a:ext cx="604757" cy="604757"/>
+          </a:xfrm>
+          <a:prstGeom prst="rect">
+            <a:avLst/>
+          </a:prstGeom>
+        </p:spPr>
+      </p:pic>
+      <p:pic>
+        <p:nvPicPr>
+          <p:cNvPr id="15" name="Picture 14" descr="Happy Laugh Woman Icon in SVG, PNG formats">
+            <a:extLst>
+              <a:ext uri="{FF2B5EF4-FFF2-40B4-BE49-F238E27FC236}">
+                <a16:creationId xmlns:a16="http://schemas.microsoft.com/office/drawing/2014/main" id="{CC91FD52-73CA-FD52-5DE4-774C358C8F5B}"/>
+              </a:ext>
+            </a:extLst>
+          </p:cNvPr>
+          <p:cNvPicPr>
+            <a:picLocks noChangeAspect="1"/>
+          </p:cNvPicPr>
+          <p:nvPr/>
+        </p:nvPicPr>
+        <p:blipFill>
+          <a:blip r:embed="rId4">
+            <a:duotone>
+              <a:schemeClr val="accent1">
+                <a:shade val="45000"/>
+                <a:satMod val="135000"/>
+              </a:schemeClr>
+              <a:prstClr val="white"/>
+            </a:duotone>
+          </a:blip>
+          <a:stretch>
+            <a:fillRect/>
+          </a:stretch>
+        </p:blipFill>
+        <p:spPr>
+          <a:xfrm>
+            <a:off x="2171837" y="775510"/>
+            <a:ext cx="604757" cy="604757"/>
+          </a:xfrm>
+          <a:prstGeom prst="rect">
+            <a:avLst/>
+          </a:prstGeom>
+        </p:spPr>
+      </p:pic>
+      <p:pic>
+        <p:nvPicPr>
+          <p:cNvPr id="17" name="Picture 16">
+            <a:extLst>
+              <a:ext uri="{FF2B5EF4-FFF2-40B4-BE49-F238E27FC236}">
+                <a16:creationId xmlns:a16="http://schemas.microsoft.com/office/drawing/2014/main" id="{AFD870DA-5AE0-4848-C823-D20568650C5D}"/>
+              </a:ext>
+            </a:extLst>
+          </p:cNvPr>
+          <p:cNvPicPr>
+            <a:picLocks noChangeAspect="1"/>
+          </p:cNvPicPr>
+          <p:nvPr/>
+        </p:nvPicPr>
+        <p:blipFill>
+          <a:blip r:embed="rId5">
+            <a:duotone>
+              <a:schemeClr val="accent1">
+                <a:shade val="45000"/>
+                <a:satMod val="135000"/>
+              </a:schemeClr>
+              <a:prstClr val="white"/>
+            </a:duotone>
+          </a:blip>
+          <a:stretch>
+            <a:fillRect/>
+          </a:stretch>
+        </p:blipFill>
+        <p:spPr>
+          <a:xfrm>
+            <a:off x="2642889" y="775510"/>
+            <a:ext cx="604757" cy="604757"/>
+          </a:xfrm>
+          <a:prstGeom prst="rect">
+            <a:avLst/>
+          </a:prstGeom>
+        </p:spPr>
+      </p:pic>
+      <p:pic>
+        <p:nvPicPr>
+          <p:cNvPr id="21" name="Picture 20" descr="Happy Laugh Woman Icon in SVG, PNG formats">
+            <a:extLst>
+              <a:ext uri="{FF2B5EF4-FFF2-40B4-BE49-F238E27FC236}">
+                <a16:creationId xmlns:a16="http://schemas.microsoft.com/office/drawing/2014/main" id="{51D4B314-89F6-A351-38CE-F2320F624FAA}"/>
+              </a:ext>
+            </a:extLst>
+          </p:cNvPr>
+          <p:cNvPicPr>
+            <a:picLocks noChangeAspect="1"/>
+          </p:cNvPicPr>
+          <p:nvPr/>
+        </p:nvPicPr>
+        <p:blipFill>
+          <a:blip r:embed="rId4">
+            <a:duotone>
+              <a:schemeClr val="accent1">
+                <a:shade val="45000"/>
+                <a:satMod val="135000"/>
+              </a:schemeClr>
+              <a:prstClr val="white"/>
+            </a:duotone>
+          </a:blip>
+          <a:stretch>
+            <a:fillRect/>
+          </a:stretch>
+        </p:blipFill>
+        <p:spPr>
+          <a:xfrm>
+            <a:off x="3102089" y="775510"/>
+            <a:ext cx="604757" cy="604757"/>
+          </a:xfrm>
+          <a:prstGeom prst="rect">
+            <a:avLst/>
+          </a:prstGeom>
+        </p:spPr>
+      </p:pic>
+      <p:pic>
+        <p:nvPicPr>
+          <p:cNvPr id="23" name="Picture 22">
+            <a:extLst>
+              <a:ext uri="{FF2B5EF4-FFF2-40B4-BE49-F238E27FC236}">
+                <a16:creationId xmlns:a16="http://schemas.microsoft.com/office/drawing/2014/main" id="{9C511E62-87AD-8EBF-B96E-020F7D3B9EA1}"/>
+              </a:ext>
+            </a:extLst>
+          </p:cNvPr>
+          <p:cNvPicPr>
+            <a:picLocks noChangeAspect="1"/>
+          </p:cNvPicPr>
+          <p:nvPr/>
+        </p:nvPicPr>
+        <p:blipFill>
+          <a:blip r:embed="rId5">
+            <a:duotone>
+              <a:schemeClr val="accent1">
+                <a:shade val="45000"/>
+                <a:satMod val="135000"/>
+              </a:schemeClr>
+              <a:prstClr val="white"/>
+            </a:duotone>
+          </a:blip>
+          <a:stretch>
+            <a:fillRect/>
+          </a:stretch>
+        </p:blipFill>
+        <p:spPr>
+          <a:xfrm>
+            <a:off x="749473" y="775510"/>
+            <a:ext cx="604757" cy="604757"/>
+          </a:xfrm>
+          <a:prstGeom prst="rect">
+            <a:avLst/>
+          </a:prstGeom>
+        </p:spPr>
+      </p:pic>
+      <p:pic>
+        <p:nvPicPr>
+          <p:cNvPr id="27" name="Picture 26">
+            <a:extLst>
+              <a:ext uri="{FF2B5EF4-FFF2-40B4-BE49-F238E27FC236}">
+                <a16:creationId xmlns:a16="http://schemas.microsoft.com/office/drawing/2014/main" id="{8ED01CE2-53E8-12A6-C291-F151E07CE867}"/>
+              </a:ext>
+            </a:extLst>
+          </p:cNvPr>
+          <p:cNvPicPr>
+            <a:picLocks noChangeAspect="1"/>
+          </p:cNvPicPr>
+          <p:nvPr/>
+        </p:nvPicPr>
+        <p:blipFill>
+          <a:blip r:embed="rId5">
+            <a:duotone>
+              <a:schemeClr val="accent1">
+                <a:shade val="45000"/>
+                <a:satMod val="135000"/>
+              </a:schemeClr>
+              <a:prstClr val="white"/>
+            </a:duotone>
+          </a:blip>
+          <a:stretch>
+            <a:fillRect/>
+          </a:stretch>
+        </p:blipFill>
+        <p:spPr>
+          <a:xfrm>
+            <a:off x="592651" y="1380267"/>
+            <a:ext cx="604757" cy="604757"/>
+          </a:xfrm>
+          <a:prstGeom prst="rect">
+            <a:avLst/>
+          </a:prstGeom>
+        </p:spPr>
+      </p:pic>
+      <p:pic>
+        <p:nvPicPr>
+          <p:cNvPr id="29" name="Picture 28" descr="Happy Laugh Woman Icon in SVG, PNG formats">
+            <a:extLst>
+              <a:ext uri="{FF2B5EF4-FFF2-40B4-BE49-F238E27FC236}">
+                <a16:creationId xmlns:a16="http://schemas.microsoft.com/office/drawing/2014/main" id="{9AD28DC5-39BD-29BC-7CE6-A5256BF9823E}"/>
+              </a:ext>
+            </a:extLst>
+          </p:cNvPr>
+          <p:cNvPicPr>
+            <a:picLocks noChangeAspect="1"/>
+          </p:cNvPicPr>
+          <p:nvPr/>
+        </p:nvPicPr>
+        <p:blipFill>
+          <a:blip r:embed="rId4">
+            <a:duotone>
+              <a:schemeClr val="accent1">
+                <a:shade val="45000"/>
+                <a:satMod val="135000"/>
+              </a:schemeClr>
+              <a:prstClr val="white"/>
+            </a:duotone>
+          </a:blip>
+          <a:stretch>
+            <a:fillRect/>
+          </a:stretch>
+        </p:blipFill>
+        <p:spPr>
+          <a:xfrm>
+            <a:off x="1032282" y="1380267"/>
+            <a:ext cx="604757" cy="604757"/>
+          </a:xfrm>
+          <a:prstGeom prst="rect">
+            <a:avLst/>
+          </a:prstGeom>
+        </p:spPr>
+      </p:pic>
+      <p:pic>
+        <p:nvPicPr>
+          <p:cNvPr id="31" name="Picture 30">
+            <a:extLst>
+              <a:ext uri="{FF2B5EF4-FFF2-40B4-BE49-F238E27FC236}">
+                <a16:creationId xmlns:a16="http://schemas.microsoft.com/office/drawing/2014/main" id="{1A3EFE33-35ED-766E-CFC8-A875F8901B0A}"/>
+              </a:ext>
+            </a:extLst>
+          </p:cNvPr>
+          <p:cNvPicPr>
+            <a:picLocks noChangeAspect="1"/>
+          </p:cNvPicPr>
+          <p:nvPr/>
+        </p:nvPicPr>
+        <p:blipFill>
+          <a:blip r:embed="rId5">
+            <a:duotone>
+              <a:schemeClr val="accent1">
+                <a:shade val="45000"/>
+                <a:satMod val="135000"/>
+              </a:schemeClr>
+              <a:prstClr val="white"/>
+            </a:duotone>
+          </a:blip>
+          <a:stretch>
+            <a:fillRect/>
+          </a:stretch>
+        </p:blipFill>
+        <p:spPr>
+          <a:xfrm>
+            <a:off x="1503334" y="1380267"/>
+            <a:ext cx="604757" cy="604757"/>
+          </a:xfrm>
+          <a:prstGeom prst="rect">
+            <a:avLst/>
+          </a:prstGeom>
+        </p:spPr>
+      </p:pic>
+      <p:pic>
+        <p:nvPicPr>
+          <p:cNvPr id="33" name="Picture 32" descr="Happy Laugh Woman Icon in SVG, PNG formats">
+            <a:extLst>
+              <a:ext uri="{FF2B5EF4-FFF2-40B4-BE49-F238E27FC236}">
+                <a16:creationId xmlns:a16="http://schemas.microsoft.com/office/drawing/2014/main" id="{D36FAD7B-CB27-7083-B273-C309E31DF28B}"/>
+              </a:ext>
+            </a:extLst>
+          </p:cNvPr>
+          <p:cNvPicPr>
+            <a:picLocks noChangeAspect="1"/>
+          </p:cNvPicPr>
+          <p:nvPr/>
+        </p:nvPicPr>
+        <p:blipFill>
+          <a:blip r:embed="rId4">
+            <a:duotone>
+              <a:schemeClr val="accent1">
+                <a:shade val="45000"/>
+                <a:satMod val="135000"/>
+              </a:schemeClr>
+              <a:prstClr val="white"/>
+            </a:duotone>
+          </a:blip>
+          <a:stretch>
+            <a:fillRect/>
+          </a:stretch>
+        </p:blipFill>
+        <p:spPr>
+          <a:xfrm>
+            <a:off x="1962534" y="1380267"/>
+            <a:ext cx="604757" cy="604757"/>
+          </a:xfrm>
+          <a:prstGeom prst="rect">
+            <a:avLst/>
+          </a:prstGeom>
+        </p:spPr>
+      </p:pic>
+      <p:pic>
+        <p:nvPicPr>
+          <p:cNvPr id="35" name="Picture 34">
+            <a:extLst>
+              <a:ext uri="{FF2B5EF4-FFF2-40B4-BE49-F238E27FC236}">
+                <a16:creationId xmlns:a16="http://schemas.microsoft.com/office/drawing/2014/main" id="{272FE4C1-4931-D0BE-779F-33CC4A4F2102}"/>
+              </a:ext>
+            </a:extLst>
+          </p:cNvPr>
+          <p:cNvPicPr>
+            <a:picLocks noChangeAspect="1"/>
+          </p:cNvPicPr>
+          <p:nvPr/>
+        </p:nvPicPr>
+        <p:blipFill>
+          <a:blip r:embed="rId5">
+            <a:duotone>
+              <a:schemeClr val="accent1">
+                <a:shade val="45000"/>
+                <a:satMod val="135000"/>
+              </a:schemeClr>
+              <a:prstClr val="white"/>
+            </a:duotone>
+          </a:blip>
+          <a:stretch>
+            <a:fillRect/>
+          </a:stretch>
+        </p:blipFill>
+        <p:spPr>
+          <a:xfrm>
+            <a:off x="2433586" y="1380267"/>
+            <a:ext cx="604757" cy="604757"/>
+          </a:xfrm>
+          <a:prstGeom prst="rect">
+            <a:avLst/>
+          </a:prstGeom>
+        </p:spPr>
+      </p:pic>
+      <p:pic>
+        <p:nvPicPr>
+          <p:cNvPr id="37" name="Picture 36" descr="Happy Laugh Woman Icon in SVG, PNG formats">
+            <a:extLst>
+              <a:ext uri="{FF2B5EF4-FFF2-40B4-BE49-F238E27FC236}">
+                <a16:creationId xmlns:a16="http://schemas.microsoft.com/office/drawing/2014/main" id="{5F1B5A78-FE89-2B19-D111-CFD79E15F01C}"/>
+              </a:ext>
+            </a:extLst>
+          </p:cNvPr>
+          <p:cNvPicPr>
+            <a:picLocks noChangeAspect="1"/>
+          </p:cNvPicPr>
+          <p:nvPr/>
+        </p:nvPicPr>
+        <p:blipFill>
+          <a:blip r:embed="rId4">
+            <a:duotone>
+              <a:schemeClr val="accent1">
+                <a:shade val="45000"/>
+                <a:satMod val="135000"/>
+              </a:schemeClr>
+              <a:prstClr val="white"/>
+            </a:duotone>
+          </a:blip>
+          <a:stretch>
+            <a:fillRect/>
+          </a:stretch>
+        </p:blipFill>
+        <p:spPr>
+          <a:xfrm>
+            <a:off x="2892786" y="1380267"/>
+            <a:ext cx="604757" cy="604757"/>
+          </a:xfrm>
+          <a:prstGeom prst="rect">
+            <a:avLst/>
+          </a:prstGeom>
+        </p:spPr>
+      </p:pic>
+      <p:pic>
+        <p:nvPicPr>
+          <p:cNvPr id="39" name="Picture 38">
+            <a:extLst>
+              <a:ext uri="{FF2B5EF4-FFF2-40B4-BE49-F238E27FC236}">
+                <a16:creationId xmlns:a16="http://schemas.microsoft.com/office/drawing/2014/main" id="{5DB35912-0196-3C04-D112-35BE2C30347F}"/>
+              </a:ext>
+            </a:extLst>
+          </p:cNvPr>
+          <p:cNvPicPr>
+            <a:picLocks noChangeAspect="1"/>
+          </p:cNvPicPr>
+          <p:nvPr/>
+        </p:nvPicPr>
+        <p:blipFill>
+          <a:blip r:embed="rId5">
+            <a:duotone>
+              <a:schemeClr val="accent1">
+                <a:shade val="45000"/>
+                <a:satMod val="135000"/>
+              </a:schemeClr>
+              <a:prstClr val="white"/>
+            </a:duotone>
+          </a:blip>
+          <a:stretch>
+            <a:fillRect/>
+          </a:stretch>
+        </p:blipFill>
+        <p:spPr>
+          <a:xfrm>
+            <a:off x="3363838" y="1380267"/>
+            <a:ext cx="604757" cy="604757"/>
+          </a:xfrm>
+          <a:prstGeom prst="rect">
+            <a:avLst/>
+          </a:prstGeom>
+        </p:spPr>
+      </p:pic>
+      <p:pic>
+        <p:nvPicPr>
+          <p:cNvPr id="43" name="Picture 42">
+            <a:extLst>
+              <a:ext uri="{FF2B5EF4-FFF2-40B4-BE49-F238E27FC236}">
+                <a16:creationId xmlns:a16="http://schemas.microsoft.com/office/drawing/2014/main" id="{45F8E978-CB31-0E31-8872-327313C1A5B5}"/>
+              </a:ext>
+            </a:extLst>
+          </p:cNvPr>
+          <p:cNvPicPr>
+            <a:picLocks noChangeAspect="1"/>
+          </p:cNvPicPr>
+          <p:nvPr/>
+        </p:nvPicPr>
+        <p:blipFill>
+          <a:blip r:embed="rId5">
+            <a:duotone>
+              <a:schemeClr val="accent1">
+                <a:shade val="45000"/>
+                <a:satMod val="135000"/>
+              </a:schemeClr>
+              <a:prstClr val="white"/>
+            </a:duotone>
+          </a:blip>
+          <a:stretch>
+            <a:fillRect/>
+          </a:stretch>
+        </p:blipFill>
+        <p:spPr>
+          <a:xfrm>
+            <a:off x="895029" y="1985024"/>
+            <a:ext cx="604757" cy="604757"/>
+          </a:xfrm>
+          <a:prstGeom prst="rect">
+            <a:avLst/>
+          </a:prstGeom>
+        </p:spPr>
+      </p:pic>
+      <p:pic>
+        <p:nvPicPr>
+          <p:cNvPr id="45" name="Picture 44" descr="Happy Laugh Woman Icon in SVG, PNG formats">
+            <a:extLst>
+              <a:ext uri="{FF2B5EF4-FFF2-40B4-BE49-F238E27FC236}">
+                <a16:creationId xmlns:a16="http://schemas.microsoft.com/office/drawing/2014/main" id="{D12A8149-480C-A511-4D1E-F49B2EAE7A16}"/>
+              </a:ext>
+            </a:extLst>
+          </p:cNvPr>
+          <p:cNvPicPr>
+            <a:picLocks noChangeAspect="1"/>
+          </p:cNvPicPr>
+          <p:nvPr/>
+        </p:nvPicPr>
+        <p:blipFill>
+          <a:blip r:embed="rId4">
+            <a:duotone>
+              <a:schemeClr val="accent1">
+                <a:shade val="45000"/>
+                <a:satMod val="135000"/>
+              </a:schemeClr>
+              <a:prstClr val="white"/>
+            </a:duotone>
+          </a:blip>
+          <a:stretch>
+            <a:fillRect/>
+          </a:stretch>
+        </p:blipFill>
+        <p:spPr>
+          <a:xfrm>
+            <a:off x="1334660" y="1985024"/>
+            <a:ext cx="604757" cy="604757"/>
+          </a:xfrm>
+          <a:prstGeom prst="rect">
+            <a:avLst/>
+          </a:prstGeom>
+        </p:spPr>
+      </p:pic>
+      <p:pic>
+        <p:nvPicPr>
+          <p:cNvPr id="47" name="Picture 46">
+            <a:extLst>
+              <a:ext uri="{FF2B5EF4-FFF2-40B4-BE49-F238E27FC236}">
+                <a16:creationId xmlns:a16="http://schemas.microsoft.com/office/drawing/2014/main" id="{91A2311F-4850-F956-872B-59EC72B0269A}"/>
+              </a:ext>
+            </a:extLst>
+          </p:cNvPr>
+          <p:cNvPicPr>
+            <a:picLocks noChangeAspect="1"/>
+          </p:cNvPicPr>
+          <p:nvPr/>
+        </p:nvPicPr>
+        <p:blipFill>
+          <a:blip r:embed="rId5">
+            <a:duotone>
+              <a:schemeClr val="accent1">
+                <a:shade val="45000"/>
+                <a:satMod val="135000"/>
+              </a:schemeClr>
+              <a:prstClr val="white"/>
+            </a:duotone>
+          </a:blip>
+          <a:stretch>
+            <a:fillRect/>
+          </a:stretch>
+        </p:blipFill>
+        <p:spPr>
+          <a:xfrm>
+            <a:off x="1805712" y="1985024"/>
+            <a:ext cx="604757" cy="604757"/>
+          </a:xfrm>
+          <a:prstGeom prst="rect">
+            <a:avLst/>
+          </a:prstGeom>
+        </p:spPr>
+      </p:pic>
+      <p:pic>
+        <p:nvPicPr>
+          <p:cNvPr id="49" name="Picture 48" descr="Happy Laugh Woman Icon in SVG, PNG formats">
+            <a:extLst>
+              <a:ext uri="{FF2B5EF4-FFF2-40B4-BE49-F238E27FC236}">
+                <a16:creationId xmlns:a16="http://schemas.microsoft.com/office/drawing/2014/main" id="{30E05FA2-08DD-23A0-9E0C-89D447A09D7C}"/>
+              </a:ext>
+            </a:extLst>
+          </p:cNvPr>
+          <p:cNvPicPr>
+            <a:picLocks noChangeAspect="1"/>
+          </p:cNvPicPr>
+          <p:nvPr/>
+        </p:nvPicPr>
+        <p:blipFill>
+          <a:blip r:embed="rId4">
+            <a:duotone>
+              <a:schemeClr val="accent1">
+                <a:shade val="45000"/>
+                <a:satMod val="135000"/>
+              </a:schemeClr>
+              <a:prstClr val="white"/>
+            </a:duotone>
+          </a:blip>
+          <a:stretch>
+            <a:fillRect/>
+          </a:stretch>
+        </p:blipFill>
+        <p:spPr>
+          <a:xfrm>
+            <a:off x="2264912" y="1985024"/>
+            <a:ext cx="604757" cy="604757"/>
+          </a:xfrm>
+          <a:prstGeom prst="rect">
+            <a:avLst/>
+          </a:prstGeom>
+        </p:spPr>
+      </p:pic>
+      <p:pic>
+        <p:nvPicPr>
+          <p:cNvPr id="51" name="Picture 50">
+            <a:extLst>
+              <a:ext uri="{FF2B5EF4-FFF2-40B4-BE49-F238E27FC236}">
+                <a16:creationId xmlns:a16="http://schemas.microsoft.com/office/drawing/2014/main" id="{2B77C547-8058-54FD-BA40-B460616AE726}"/>
+              </a:ext>
+            </a:extLst>
+          </p:cNvPr>
+          <p:cNvPicPr>
+            <a:picLocks noChangeAspect="1"/>
+          </p:cNvPicPr>
+          <p:nvPr/>
+        </p:nvPicPr>
+        <p:blipFill>
+          <a:blip r:embed="rId5">
+            <a:duotone>
+              <a:schemeClr val="accent1">
+                <a:shade val="45000"/>
+                <a:satMod val="135000"/>
+              </a:schemeClr>
+              <a:prstClr val="white"/>
+            </a:duotone>
+          </a:blip>
+          <a:stretch>
+            <a:fillRect/>
+          </a:stretch>
+        </p:blipFill>
+        <p:spPr>
+          <a:xfrm>
+            <a:off x="2735964" y="1985024"/>
+            <a:ext cx="604757" cy="604757"/>
+          </a:xfrm>
+          <a:prstGeom prst="rect">
+            <a:avLst/>
+          </a:prstGeom>
+        </p:spPr>
+      </p:pic>
+      <p:pic>
+        <p:nvPicPr>
+          <p:cNvPr id="53" name="Picture 52" descr="Happy Laugh Woman Icon in SVG, PNG formats">
+            <a:extLst>
+              <a:ext uri="{FF2B5EF4-FFF2-40B4-BE49-F238E27FC236}">
+                <a16:creationId xmlns:a16="http://schemas.microsoft.com/office/drawing/2014/main" id="{268B99B6-9EB9-A056-30E7-47CF4F28258E}"/>
+              </a:ext>
+            </a:extLst>
+          </p:cNvPr>
+          <p:cNvPicPr>
+            <a:picLocks noChangeAspect="1"/>
+          </p:cNvPicPr>
+          <p:nvPr/>
+        </p:nvPicPr>
+        <p:blipFill>
+          <a:blip r:embed="rId4">
+            <a:duotone>
+              <a:schemeClr val="accent1">
+                <a:shade val="45000"/>
+                <a:satMod val="135000"/>
+              </a:schemeClr>
+              <a:prstClr val="white"/>
+            </a:duotone>
+          </a:blip>
+          <a:stretch>
+            <a:fillRect/>
+          </a:stretch>
+        </p:blipFill>
+        <p:spPr>
+          <a:xfrm>
+            <a:off x="3195164" y="1985024"/>
+            <a:ext cx="604757" cy="604757"/>
+          </a:xfrm>
+          <a:prstGeom prst="rect">
+            <a:avLst/>
+          </a:prstGeom>
+        </p:spPr>
+      </p:pic>
+      <p:pic>
+        <p:nvPicPr>
+          <p:cNvPr id="61" name="Picture 60" descr="Happy Laugh Woman Icon in SVG, PNG formats">
+            <a:extLst>
+              <a:ext uri="{FF2B5EF4-FFF2-40B4-BE49-F238E27FC236}">
+                <a16:creationId xmlns:a16="http://schemas.microsoft.com/office/drawing/2014/main" id="{93DD0F5C-C233-71FE-1319-EEFDEA55CAF2}"/>
+              </a:ext>
+            </a:extLst>
+          </p:cNvPr>
+          <p:cNvPicPr>
+            <a:picLocks noChangeAspect="1"/>
+          </p:cNvPicPr>
+          <p:nvPr/>
+        </p:nvPicPr>
+        <p:blipFill>
+          <a:blip r:embed="rId4">
+            <a:duotone>
+              <a:schemeClr val="accent1">
+                <a:shade val="45000"/>
+                <a:satMod val="135000"/>
+              </a:schemeClr>
+              <a:prstClr val="white"/>
+            </a:duotone>
+          </a:blip>
+          <a:stretch>
+            <a:fillRect/>
+          </a:stretch>
+        </p:blipFill>
+        <p:spPr>
+          <a:xfrm>
+            <a:off x="636828" y="2589781"/>
+            <a:ext cx="604757" cy="604757"/>
+          </a:xfrm>
+          <a:prstGeom prst="rect">
+            <a:avLst/>
+          </a:prstGeom>
+        </p:spPr>
+      </p:pic>
+      <p:pic>
+        <p:nvPicPr>
+          <p:cNvPr id="63" name="Picture 62">
+            <a:extLst>
+              <a:ext uri="{FF2B5EF4-FFF2-40B4-BE49-F238E27FC236}">
+                <a16:creationId xmlns:a16="http://schemas.microsoft.com/office/drawing/2014/main" id="{667DFCBE-E1A4-C15D-E756-E906181367E3}"/>
+              </a:ext>
+            </a:extLst>
+          </p:cNvPr>
+          <p:cNvPicPr>
+            <a:picLocks noChangeAspect="1"/>
+          </p:cNvPicPr>
+          <p:nvPr/>
+        </p:nvPicPr>
+        <p:blipFill>
+          <a:blip r:embed="rId5">
+            <a:duotone>
+              <a:schemeClr val="accent1">
+                <a:shade val="45000"/>
+                <a:satMod val="135000"/>
+              </a:schemeClr>
+              <a:prstClr val="white"/>
+            </a:duotone>
+          </a:blip>
+          <a:stretch>
+            <a:fillRect/>
+          </a:stretch>
+        </p:blipFill>
+        <p:spPr>
+          <a:xfrm>
+            <a:off x="1107880" y="2589781"/>
+            <a:ext cx="604757" cy="604757"/>
+          </a:xfrm>
+          <a:prstGeom prst="rect">
+            <a:avLst/>
+          </a:prstGeom>
+        </p:spPr>
+      </p:pic>
+      <p:pic>
+        <p:nvPicPr>
+          <p:cNvPr id="65" name="Picture 64" descr="Happy Laugh Woman Icon in SVG, PNG formats">
+            <a:extLst>
+              <a:ext uri="{FF2B5EF4-FFF2-40B4-BE49-F238E27FC236}">
+                <a16:creationId xmlns:a16="http://schemas.microsoft.com/office/drawing/2014/main" id="{DA089CE9-5A95-BA99-DC53-DBB9E23C7E1B}"/>
+              </a:ext>
+            </a:extLst>
+          </p:cNvPr>
+          <p:cNvPicPr>
+            <a:picLocks noChangeAspect="1"/>
+          </p:cNvPicPr>
+          <p:nvPr/>
+        </p:nvPicPr>
+        <p:blipFill>
+          <a:blip r:embed="rId4">
+            <a:duotone>
+              <a:schemeClr val="accent1">
+                <a:shade val="45000"/>
+                <a:satMod val="135000"/>
+              </a:schemeClr>
+              <a:prstClr val="white"/>
+            </a:duotone>
+          </a:blip>
+          <a:stretch>
+            <a:fillRect/>
+          </a:stretch>
+        </p:blipFill>
+        <p:spPr>
+          <a:xfrm>
+            <a:off x="1567080" y="2589781"/>
+            <a:ext cx="604757" cy="604757"/>
+          </a:xfrm>
+          <a:prstGeom prst="rect">
+            <a:avLst/>
+          </a:prstGeom>
+        </p:spPr>
+      </p:pic>
+      <p:pic>
+        <p:nvPicPr>
+          <p:cNvPr id="67" name="Picture 66">
+            <a:extLst>
+              <a:ext uri="{FF2B5EF4-FFF2-40B4-BE49-F238E27FC236}">
+                <a16:creationId xmlns:a16="http://schemas.microsoft.com/office/drawing/2014/main" id="{99B88B1C-CC5D-C3CE-3252-4DE789D38240}"/>
+              </a:ext>
+            </a:extLst>
+          </p:cNvPr>
+          <p:cNvPicPr>
+            <a:picLocks noChangeAspect="1"/>
+          </p:cNvPicPr>
+          <p:nvPr/>
+        </p:nvPicPr>
+        <p:blipFill>
+          <a:blip r:embed="rId5">
+            <a:duotone>
+              <a:schemeClr val="accent1">
+                <a:shade val="45000"/>
+                <a:satMod val="135000"/>
+              </a:schemeClr>
+              <a:prstClr val="white"/>
+            </a:duotone>
+          </a:blip>
+          <a:stretch>
+            <a:fillRect/>
+          </a:stretch>
+        </p:blipFill>
+        <p:spPr>
+          <a:xfrm>
+            <a:off x="2038132" y="2589781"/>
+            <a:ext cx="604757" cy="604757"/>
+          </a:xfrm>
+          <a:prstGeom prst="rect">
+            <a:avLst/>
+          </a:prstGeom>
+        </p:spPr>
+      </p:pic>
+      <p:pic>
+        <p:nvPicPr>
+          <p:cNvPr id="69" name="Picture 68" descr="Happy Laugh Woman Icon in SVG, PNG formats">
+            <a:extLst>
+              <a:ext uri="{FF2B5EF4-FFF2-40B4-BE49-F238E27FC236}">
+                <a16:creationId xmlns:a16="http://schemas.microsoft.com/office/drawing/2014/main" id="{E7B7EACE-5B3D-0BAA-AD22-4272EBDE3BC4}"/>
+              </a:ext>
+            </a:extLst>
+          </p:cNvPr>
+          <p:cNvPicPr>
+            <a:picLocks noChangeAspect="1"/>
+          </p:cNvPicPr>
+          <p:nvPr/>
+        </p:nvPicPr>
+        <p:blipFill>
+          <a:blip r:embed="rId4">
+            <a:duotone>
+              <a:schemeClr val="accent1">
+                <a:shade val="45000"/>
+                <a:satMod val="135000"/>
+              </a:schemeClr>
+              <a:prstClr val="white"/>
+            </a:duotone>
+          </a:blip>
+          <a:stretch>
+            <a:fillRect/>
+          </a:stretch>
+        </p:blipFill>
+        <p:spPr>
+          <a:xfrm>
+            <a:off x="2497332" y="2589781"/>
+            <a:ext cx="604757" cy="604757"/>
+          </a:xfrm>
+          <a:prstGeom prst="rect">
+            <a:avLst/>
+          </a:prstGeom>
+        </p:spPr>
+      </p:pic>
+      <p:pic>
+        <p:nvPicPr>
+          <p:cNvPr id="71" name="Picture 70">
+            <a:extLst>
+              <a:ext uri="{FF2B5EF4-FFF2-40B4-BE49-F238E27FC236}">
+                <a16:creationId xmlns:a16="http://schemas.microsoft.com/office/drawing/2014/main" id="{7FAA7608-EA93-0043-98B7-11906490FB70}"/>
+              </a:ext>
+            </a:extLst>
+          </p:cNvPr>
+          <p:cNvPicPr>
+            <a:picLocks noChangeAspect="1"/>
+          </p:cNvPicPr>
+          <p:nvPr/>
+        </p:nvPicPr>
+        <p:blipFill>
+          <a:blip r:embed="rId5">
+            <a:duotone>
+              <a:schemeClr val="accent1">
+                <a:shade val="45000"/>
+                <a:satMod val="135000"/>
+              </a:schemeClr>
+              <a:prstClr val="white"/>
+            </a:duotone>
+          </a:blip>
+          <a:stretch>
+            <a:fillRect/>
+          </a:stretch>
+        </p:blipFill>
+        <p:spPr>
+          <a:xfrm>
+            <a:off x="2968384" y="2589781"/>
+            <a:ext cx="604757" cy="604757"/>
+          </a:xfrm>
+          <a:prstGeom prst="rect">
+            <a:avLst/>
+          </a:prstGeom>
+        </p:spPr>
+      </p:pic>
+      <p:pic>
+        <p:nvPicPr>
+          <p:cNvPr id="73" name="Picture 72" descr="Happy Laugh Woman Icon in SVG, PNG formats">
+            <a:extLst>
+              <a:ext uri="{FF2B5EF4-FFF2-40B4-BE49-F238E27FC236}">
+                <a16:creationId xmlns:a16="http://schemas.microsoft.com/office/drawing/2014/main" id="{B3A091D4-BFD4-671B-8702-12900541F4FD}"/>
+              </a:ext>
+            </a:extLst>
+          </p:cNvPr>
+          <p:cNvPicPr>
+            <a:picLocks noChangeAspect="1"/>
+          </p:cNvPicPr>
+          <p:nvPr/>
+        </p:nvPicPr>
+        <p:blipFill>
+          <a:blip r:embed="rId4">
+            <a:duotone>
+              <a:schemeClr val="accent1">
+                <a:shade val="45000"/>
+                <a:satMod val="135000"/>
+              </a:schemeClr>
+              <a:prstClr val="white"/>
+            </a:duotone>
+          </a:blip>
+          <a:stretch>
+            <a:fillRect/>
+          </a:stretch>
+        </p:blipFill>
+        <p:spPr>
+          <a:xfrm>
+            <a:off x="5064713" y="789145"/>
+            <a:ext cx="604757" cy="604757"/>
+          </a:xfrm>
+          <a:prstGeom prst="rect">
+            <a:avLst/>
+          </a:prstGeom>
+        </p:spPr>
+      </p:pic>
+      <p:pic>
+        <p:nvPicPr>
+          <p:cNvPr id="75" name="Picture 74">
+            <a:extLst>
+              <a:ext uri="{FF2B5EF4-FFF2-40B4-BE49-F238E27FC236}">
+                <a16:creationId xmlns:a16="http://schemas.microsoft.com/office/drawing/2014/main" id="{A7DB8B97-7DCF-F659-AEFF-92DFB7E456A9}"/>
+              </a:ext>
+            </a:extLst>
+          </p:cNvPr>
+          <p:cNvPicPr>
+            <a:picLocks noChangeAspect="1"/>
+          </p:cNvPicPr>
+          <p:nvPr/>
+        </p:nvPicPr>
+        <p:blipFill>
+          <a:blip r:embed="rId5">
+            <a:duotone>
+              <a:schemeClr val="accent1">
+                <a:shade val="45000"/>
+                <a:satMod val="135000"/>
+              </a:schemeClr>
+              <a:prstClr val="white"/>
+            </a:duotone>
+          </a:blip>
+          <a:stretch>
+            <a:fillRect/>
+          </a:stretch>
+        </p:blipFill>
+        <p:spPr>
+          <a:xfrm>
+            <a:off x="5535765" y="789145"/>
+            <a:ext cx="604757" cy="604757"/>
+          </a:xfrm>
+          <a:prstGeom prst="rect">
+            <a:avLst/>
+          </a:prstGeom>
+        </p:spPr>
+      </p:pic>
+      <p:pic>
+        <p:nvPicPr>
+          <p:cNvPr id="77" name="Picture 76" descr="Happy Laugh Woman Icon in SVG, PNG formats">
+            <a:extLst>
+              <a:ext uri="{FF2B5EF4-FFF2-40B4-BE49-F238E27FC236}">
+                <a16:creationId xmlns:a16="http://schemas.microsoft.com/office/drawing/2014/main" id="{B76E67E9-FA0E-8853-DCB3-A9BA72DEFD4B}"/>
+              </a:ext>
+            </a:extLst>
+          </p:cNvPr>
+          <p:cNvPicPr>
+            <a:picLocks noChangeAspect="1"/>
+          </p:cNvPicPr>
+          <p:nvPr/>
+        </p:nvPicPr>
+        <p:blipFill>
+          <a:blip r:embed="rId4">
+            <a:duotone>
+              <a:schemeClr val="accent1">
+                <a:shade val="45000"/>
+                <a:satMod val="135000"/>
+              </a:schemeClr>
+              <a:prstClr val="white"/>
+            </a:duotone>
+          </a:blip>
+          <a:stretch>
+            <a:fillRect/>
+          </a:stretch>
+        </p:blipFill>
+        <p:spPr>
+          <a:xfrm>
+            <a:off x="5994965" y="789145"/>
+            <a:ext cx="604757" cy="604757"/>
+          </a:xfrm>
+          <a:prstGeom prst="rect">
+            <a:avLst/>
+          </a:prstGeom>
+        </p:spPr>
+      </p:pic>
+      <p:pic>
+        <p:nvPicPr>
+          <p:cNvPr id="79" name="Picture 78">
+            <a:extLst>
+              <a:ext uri="{FF2B5EF4-FFF2-40B4-BE49-F238E27FC236}">
+                <a16:creationId xmlns:a16="http://schemas.microsoft.com/office/drawing/2014/main" id="{1DE0BFE3-989D-7ECA-A702-B9A3049EF072}"/>
+              </a:ext>
+            </a:extLst>
+          </p:cNvPr>
+          <p:cNvPicPr>
+            <a:picLocks noChangeAspect="1"/>
+          </p:cNvPicPr>
+          <p:nvPr/>
+        </p:nvPicPr>
+        <p:blipFill>
+          <a:blip r:embed="rId5">
+            <a:duotone>
+              <a:schemeClr val="accent1">
+                <a:shade val="45000"/>
+                <a:satMod val="135000"/>
+              </a:schemeClr>
+              <a:prstClr val="white"/>
+            </a:duotone>
+          </a:blip>
+          <a:stretch>
+            <a:fillRect/>
+          </a:stretch>
+        </p:blipFill>
+        <p:spPr>
+          <a:xfrm>
+            <a:off x="6466017" y="789145"/>
+            <a:ext cx="604757" cy="604757"/>
+          </a:xfrm>
+          <a:prstGeom prst="rect">
+            <a:avLst/>
+          </a:prstGeom>
+        </p:spPr>
+      </p:pic>
+      <p:pic>
+        <p:nvPicPr>
+          <p:cNvPr id="81" name="Picture 80" descr="Happy Laugh Woman Icon in SVG, PNG formats">
+            <a:extLst>
+              <a:ext uri="{FF2B5EF4-FFF2-40B4-BE49-F238E27FC236}">
+                <a16:creationId xmlns:a16="http://schemas.microsoft.com/office/drawing/2014/main" id="{0C2C5BB4-2D9D-A560-4F38-7A199EA5A7C0}"/>
+              </a:ext>
+            </a:extLst>
+          </p:cNvPr>
+          <p:cNvPicPr>
+            <a:picLocks noChangeAspect="1"/>
+          </p:cNvPicPr>
+          <p:nvPr/>
+        </p:nvPicPr>
+        <p:blipFill>
+          <a:blip r:embed="rId4">
+            <a:duotone>
+              <a:schemeClr val="accent1">
+                <a:shade val="45000"/>
+                <a:satMod val="135000"/>
+              </a:schemeClr>
+              <a:prstClr val="white"/>
+            </a:duotone>
+          </a:blip>
+          <a:stretch>
+            <a:fillRect/>
+          </a:stretch>
+        </p:blipFill>
+        <p:spPr>
+          <a:xfrm>
+            <a:off x="6925217" y="789145"/>
+            <a:ext cx="604757" cy="604757"/>
+          </a:xfrm>
+          <a:prstGeom prst="rect">
+            <a:avLst/>
+          </a:prstGeom>
+        </p:spPr>
+      </p:pic>
+      <p:pic>
+        <p:nvPicPr>
+          <p:cNvPr id="83" name="Picture 82">
+            <a:extLst>
+              <a:ext uri="{FF2B5EF4-FFF2-40B4-BE49-F238E27FC236}">
+                <a16:creationId xmlns:a16="http://schemas.microsoft.com/office/drawing/2014/main" id="{4C384736-5BFF-EF8B-5139-4244C1D37649}"/>
+              </a:ext>
+            </a:extLst>
+          </p:cNvPr>
+          <p:cNvPicPr>
+            <a:picLocks noChangeAspect="1"/>
+          </p:cNvPicPr>
+          <p:nvPr/>
+        </p:nvPicPr>
+        <p:blipFill>
+          <a:blip r:embed="rId5">
+            <a:duotone>
+              <a:schemeClr val="accent1">
+                <a:shade val="45000"/>
+                <a:satMod val="135000"/>
+              </a:schemeClr>
+              <a:prstClr val="white"/>
+            </a:duotone>
+          </a:blip>
+          <a:stretch>
+            <a:fillRect/>
+          </a:stretch>
+        </p:blipFill>
+        <p:spPr>
+          <a:xfrm>
+            <a:off x="4572601" y="789145"/>
+            <a:ext cx="604757" cy="604757"/>
+          </a:xfrm>
+          <a:prstGeom prst="rect">
+            <a:avLst/>
+          </a:prstGeom>
+        </p:spPr>
+      </p:pic>
+      <p:pic>
+        <p:nvPicPr>
+          <p:cNvPr id="85" name="Picture 84">
+            <a:extLst>
+              <a:ext uri="{FF2B5EF4-FFF2-40B4-BE49-F238E27FC236}">
+                <a16:creationId xmlns:a16="http://schemas.microsoft.com/office/drawing/2014/main" id="{A4555BA1-DEAD-92C9-8D49-4CF7C8B5D6CE}"/>
+              </a:ext>
+            </a:extLst>
+          </p:cNvPr>
+          <p:cNvPicPr>
+            <a:picLocks noChangeAspect="1"/>
+          </p:cNvPicPr>
+          <p:nvPr/>
+        </p:nvPicPr>
+        <p:blipFill>
+          <a:blip r:embed="rId5">
+            <a:duotone>
+              <a:schemeClr val="accent1">
+                <a:shade val="45000"/>
+                <a:satMod val="135000"/>
+              </a:schemeClr>
+              <a:prstClr val="white"/>
+            </a:duotone>
+          </a:blip>
+          <a:stretch>
+            <a:fillRect/>
+          </a:stretch>
+        </p:blipFill>
+        <p:spPr>
+          <a:xfrm>
+            <a:off x="4415779" y="1393902"/>
+            <a:ext cx="604757" cy="604757"/>
+          </a:xfrm>
+          <a:prstGeom prst="rect">
+            <a:avLst/>
+          </a:prstGeom>
+        </p:spPr>
+      </p:pic>
+      <p:pic>
+        <p:nvPicPr>
+          <p:cNvPr id="87" name="Picture 86" descr="Happy Laugh Woman Icon in SVG, PNG formats">
+            <a:extLst>
+              <a:ext uri="{FF2B5EF4-FFF2-40B4-BE49-F238E27FC236}">
+                <a16:creationId xmlns:a16="http://schemas.microsoft.com/office/drawing/2014/main" id="{017B87CD-8CC6-5FF1-8EB3-BADF7B0E2EA5}"/>
+              </a:ext>
+            </a:extLst>
+          </p:cNvPr>
+          <p:cNvPicPr>
+            <a:picLocks noChangeAspect="1"/>
+          </p:cNvPicPr>
+          <p:nvPr/>
+        </p:nvPicPr>
+        <p:blipFill>
+          <a:blip r:embed="rId4">
+            <a:duotone>
+              <a:schemeClr val="accent1">
+                <a:shade val="45000"/>
+                <a:satMod val="135000"/>
+              </a:schemeClr>
+              <a:prstClr val="white"/>
+            </a:duotone>
+          </a:blip>
+          <a:stretch>
+            <a:fillRect/>
+          </a:stretch>
+        </p:blipFill>
+        <p:spPr>
+          <a:xfrm>
+            <a:off x="4855410" y="1393902"/>
+            <a:ext cx="604757" cy="604757"/>
+          </a:xfrm>
+          <a:prstGeom prst="rect">
+            <a:avLst/>
+          </a:prstGeom>
+        </p:spPr>
+      </p:pic>
+      <p:pic>
+        <p:nvPicPr>
+          <p:cNvPr id="89" name="Picture 88">
+            <a:extLst>
+              <a:ext uri="{FF2B5EF4-FFF2-40B4-BE49-F238E27FC236}">
+                <a16:creationId xmlns:a16="http://schemas.microsoft.com/office/drawing/2014/main" id="{651BC68E-7CB7-5EA7-A795-6C2041577540}"/>
+              </a:ext>
+            </a:extLst>
+          </p:cNvPr>
+          <p:cNvPicPr>
+            <a:picLocks noChangeAspect="1"/>
+          </p:cNvPicPr>
+          <p:nvPr/>
+        </p:nvPicPr>
+        <p:blipFill>
+          <a:blip r:embed="rId5">
+            <a:duotone>
+              <a:schemeClr val="accent1">
+                <a:shade val="45000"/>
+                <a:satMod val="135000"/>
+              </a:schemeClr>
+              <a:prstClr val="white"/>
+            </a:duotone>
+          </a:blip>
+          <a:stretch>
+            <a:fillRect/>
+          </a:stretch>
+        </p:blipFill>
+        <p:spPr>
+          <a:xfrm>
+            <a:off x="5326462" y="1393902"/>
+            <a:ext cx="604757" cy="604757"/>
+          </a:xfrm>
+          <a:prstGeom prst="rect">
+            <a:avLst/>
+          </a:prstGeom>
+        </p:spPr>
+      </p:pic>
+      <p:pic>
+        <p:nvPicPr>
+          <p:cNvPr id="91" name="Picture 90" descr="Happy Laugh Woman Icon in SVG, PNG formats">
+            <a:extLst>
+              <a:ext uri="{FF2B5EF4-FFF2-40B4-BE49-F238E27FC236}">
+                <a16:creationId xmlns:a16="http://schemas.microsoft.com/office/drawing/2014/main" id="{A25BC524-AD1E-2EE6-F93B-9ADFB4D8FE58}"/>
+              </a:ext>
+            </a:extLst>
+          </p:cNvPr>
+          <p:cNvPicPr>
+            <a:picLocks noChangeAspect="1"/>
+          </p:cNvPicPr>
+          <p:nvPr/>
+        </p:nvPicPr>
+        <p:blipFill>
+          <a:blip r:embed="rId4">
+            <a:duotone>
+              <a:schemeClr val="accent1">
+                <a:shade val="45000"/>
+                <a:satMod val="135000"/>
+              </a:schemeClr>
+              <a:prstClr val="white"/>
+            </a:duotone>
+          </a:blip>
+          <a:stretch>
+            <a:fillRect/>
+          </a:stretch>
+        </p:blipFill>
+        <p:spPr>
+          <a:xfrm>
+            <a:off x="5785662" y="1393902"/>
+            <a:ext cx="604757" cy="604757"/>
+          </a:xfrm>
+          <a:prstGeom prst="rect">
+            <a:avLst/>
+          </a:prstGeom>
+        </p:spPr>
+      </p:pic>
+      <p:pic>
+        <p:nvPicPr>
+          <p:cNvPr id="93" name="Picture 92">
+            <a:extLst>
+              <a:ext uri="{FF2B5EF4-FFF2-40B4-BE49-F238E27FC236}">
+                <a16:creationId xmlns:a16="http://schemas.microsoft.com/office/drawing/2014/main" id="{840FC3C1-55F9-2D78-ED01-03CD3109DDB7}"/>
+              </a:ext>
+            </a:extLst>
+          </p:cNvPr>
+          <p:cNvPicPr>
+            <a:picLocks noChangeAspect="1"/>
+          </p:cNvPicPr>
+          <p:nvPr/>
+        </p:nvPicPr>
+        <p:blipFill>
+          <a:blip r:embed="rId5">
+            <a:duotone>
+              <a:schemeClr val="accent1">
+                <a:shade val="45000"/>
+                <a:satMod val="135000"/>
+              </a:schemeClr>
+              <a:prstClr val="white"/>
+            </a:duotone>
+          </a:blip>
+          <a:stretch>
+            <a:fillRect/>
+          </a:stretch>
+        </p:blipFill>
+        <p:spPr>
+          <a:xfrm>
+            <a:off x="6256714" y="1393902"/>
+            <a:ext cx="604757" cy="604757"/>
+          </a:xfrm>
+          <a:prstGeom prst="rect">
+            <a:avLst/>
+          </a:prstGeom>
+        </p:spPr>
+      </p:pic>
+      <p:pic>
+        <p:nvPicPr>
+          <p:cNvPr id="95" name="Picture 94" descr="Happy Laugh Woman Icon in SVG, PNG formats">
+            <a:extLst>
+              <a:ext uri="{FF2B5EF4-FFF2-40B4-BE49-F238E27FC236}">
+                <a16:creationId xmlns:a16="http://schemas.microsoft.com/office/drawing/2014/main" id="{3574C791-17D5-9EBE-1374-E2111E1EA136}"/>
+              </a:ext>
+            </a:extLst>
+          </p:cNvPr>
+          <p:cNvPicPr>
+            <a:picLocks noChangeAspect="1"/>
+          </p:cNvPicPr>
+          <p:nvPr/>
+        </p:nvPicPr>
+        <p:blipFill>
+          <a:blip r:embed="rId4">
+            <a:duotone>
+              <a:schemeClr val="accent1">
+                <a:shade val="45000"/>
+                <a:satMod val="135000"/>
+              </a:schemeClr>
+              <a:prstClr val="white"/>
+            </a:duotone>
+          </a:blip>
+          <a:stretch>
+            <a:fillRect/>
+          </a:stretch>
+        </p:blipFill>
+        <p:spPr>
+          <a:xfrm>
+            <a:off x="6715914" y="1393902"/>
+            <a:ext cx="604757" cy="604757"/>
+          </a:xfrm>
+          <a:prstGeom prst="rect">
+            <a:avLst/>
+          </a:prstGeom>
+        </p:spPr>
+      </p:pic>
+      <p:pic>
+        <p:nvPicPr>
+          <p:cNvPr id="97" name="Picture 96">
+            <a:extLst>
+              <a:ext uri="{FF2B5EF4-FFF2-40B4-BE49-F238E27FC236}">
+                <a16:creationId xmlns:a16="http://schemas.microsoft.com/office/drawing/2014/main" id="{8321CAFB-C8FE-BBE3-3B74-6429E9FB193F}"/>
+              </a:ext>
+            </a:extLst>
+          </p:cNvPr>
+          <p:cNvPicPr>
+            <a:picLocks noChangeAspect="1"/>
+          </p:cNvPicPr>
+          <p:nvPr/>
+        </p:nvPicPr>
+        <p:blipFill>
+          <a:blip r:embed="rId5">
+            <a:duotone>
+              <a:schemeClr val="accent1">
+                <a:shade val="45000"/>
+                <a:satMod val="135000"/>
+              </a:schemeClr>
+              <a:prstClr val="white"/>
+            </a:duotone>
+          </a:blip>
+          <a:stretch>
+            <a:fillRect/>
+          </a:stretch>
+        </p:blipFill>
+        <p:spPr>
+          <a:xfrm>
+            <a:off x="7186966" y="1393902"/>
+            <a:ext cx="604757" cy="604757"/>
+          </a:xfrm>
+          <a:prstGeom prst="rect">
+            <a:avLst/>
+          </a:prstGeom>
+        </p:spPr>
+      </p:pic>
+      <p:pic>
+        <p:nvPicPr>
+          <p:cNvPr id="99" name="Picture 98">
+            <a:extLst>
+              <a:ext uri="{FF2B5EF4-FFF2-40B4-BE49-F238E27FC236}">
+                <a16:creationId xmlns:a16="http://schemas.microsoft.com/office/drawing/2014/main" id="{7D8A13A0-6380-8887-F72F-C9C7D4586769}"/>
+              </a:ext>
+            </a:extLst>
+          </p:cNvPr>
+          <p:cNvPicPr>
+            <a:picLocks noChangeAspect="1"/>
+          </p:cNvPicPr>
+          <p:nvPr/>
+        </p:nvPicPr>
+        <p:blipFill>
+          <a:blip r:embed="rId5">
+            <a:duotone>
+              <a:schemeClr val="accent1">
+                <a:shade val="45000"/>
+                <a:satMod val="135000"/>
+              </a:schemeClr>
+              <a:prstClr val="white"/>
+            </a:duotone>
+          </a:blip>
+          <a:stretch>
+            <a:fillRect/>
+          </a:stretch>
+        </p:blipFill>
+        <p:spPr>
+          <a:xfrm>
+            <a:off x="4718157" y="1998659"/>
+            <a:ext cx="604757" cy="604757"/>
+          </a:xfrm>
+          <a:prstGeom prst="rect">
+            <a:avLst/>
+          </a:prstGeom>
+        </p:spPr>
+      </p:pic>
+      <p:pic>
+        <p:nvPicPr>
+          <p:cNvPr id="101" name="Picture 100" descr="Happy Laugh Woman Icon in SVG, PNG formats">
+            <a:extLst>
+              <a:ext uri="{FF2B5EF4-FFF2-40B4-BE49-F238E27FC236}">
+                <a16:creationId xmlns:a16="http://schemas.microsoft.com/office/drawing/2014/main" id="{27522E1A-AAD9-10E1-50C7-EF3DF77DFB86}"/>
+              </a:ext>
+            </a:extLst>
+          </p:cNvPr>
+          <p:cNvPicPr>
+            <a:picLocks noChangeAspect="1"/>
+          </p:cNvPicPr>
+          <p:nvPr/>
+        </p:nvPicPr>
+        <p:blipFill>
+          <a:blip r:embed="rId4">
+            <a:duotone>
+              <a:schemeClr val="accent1">
+                <a:shade val="45000"/>
+                <a:satMod val="135000"/>
+              </a:schemeClr>
+              <a:prstClr val="white"/>
+            </a:duotone>
+          </a:blip>
+          <a:stretch>
+            <a:fillRect/>
+          </a:stretch>
+        </p:blipFill>
+        <p:spPr>
+          <a:xfrm>
+            <a:off x="5157788" y="1998659"/>
+            <a:ext cx="604757" cy="604757"/>
+          </a:xfrm>
+          <a:prstGeom prst="rect">
+            <a:avLst/>
+          </a:prstGeom>
+        </p:spPr>
+      </p:pic>
+      <p:pic>
+        <p:nvPicPr>
+          <p:cNvPr id="103" name="Picture 102">
+            <a:extLst>
+              <a:ext uri="{FF2B5EF4-FFF2-40B4-BE49-F238E27FC236}">
+                <a16:creationId xmlns:a16="http://schemas.microsoft.com/office/drawing/2014/main" id="{3F584D5D-7EBD-FC1E-0BAC-1313841F07D3}"/>
+              </a:ext>
+            </a:extLst>
+          </p:cNvPr>
+          <p:cNvPicPr>
+            <a:picLocks noChangeAspect="1"/>
+          </p:cNvPicPr>
+          <p:nvPr/>
+        </p:nvPicPr>
+        <p:blipFill>
+          <a:blip r:embed="rId5">
+            <a:duotone>
+              <a:schemeClr val="accent1">
+                <a:shade val="45000"/>
+                <a:satMod val="135000"/>
+              </a:schemeClr>
+              <a:prstClr val="white"/>
+            </a:duotone>
+          </a:blip>
+          <a:stretch>
+            <a:fillRect/>
+          </a:stretch>
+        </p:blipFill>
+        <p:spPr>
+          <a:xfrm>
+            <a:off x="5628840" y="1998659"/>
+            <a:ext cx="604757" cy="604757"/>
+          </a:xfrm>
+          <a:prstGeom prst="rect">
+            <a:avLst/>
+          </a:prstGeom>
+        </p:spPr>
+      </p:pic>
+      <p:pic>
+        <p:nvPicPr>
+          <p:cNvPr id="105" name="Picture 104" descr="Happy Laugh Woman Icon in SVG, PNG formats">
+            <a:extLst>
+              <a:ext uri="{FF2B5EF4-FFF2-40B4-BE49-F238E27FC236}">
+                <a16:creationId xmlns:a16="http://schemas.microsoft.com/office/drawing/2014/main" id="{F01E8DC1-81ED-65FE-14CC-B0EE0724E3BD}"/>
+              </a:ext>
+            </a:extLst>
+          </p:cNvPr>
+          <p:cNvPicPr>
+            <a:picLocks noChangeAspect="1"/>
+          </p:cNvPicPr>
+          <p:nvPr/>
+        </p:nvPicPr>
+        <p:blipFill>
+          <a:blip r:embed="rId4">
+            <a:duotone>
+              <a:schemeClr val="accent1">
+                <a:shade val="45000"/>
+                <a:satMod val="135000"/>
+              </a:schemeClr>
+              <a:prstClr val="white"/>
+            </a:duotone>
+          </a:blip>
+          <a:stretch>
+            <a:fillRect/>
+          </a:stretch>
+        </p:blipFill>
+        <p:spPr>
+          <a:xfrm>
+            <a:off x="6088040" y="1998659"/>
+            <a:ext cx="604757" cy="604757"/>
+          </a:xfrm>
+          <a:prstGeom prst="rect">
+            <a:avLst/>
+          </a:prstGeom>
+        </p:spPr>
+      </p:pic>
+      <p:pic>
+        <p:nvPicPr>
+          <p:cNvPr id="111" name="Picture 110" descr="Happy Laugh Woman Icon in SVG, PNG formats">
+            <a:extLst>
+              <a:ext uri="{FF2B5EF4-FFF2-40B4-BE49-F238E27FC236}">
+                <a16:creationId xmlns:a16="http://schemas.microsoft.com/office/drawing/2014/main" id="{6DB18AE1-126B-88B5-C989-7884321511E3}"/>
+              </a:ext>
+            </a:extLst>
+          </p:cNvPr>
+          <p:cNvPicPr>
+            <a:picLocks noChangeAspect="1"/>
+          </p:cNvPicPr>
+          <p:nvPr/>
+        </p:nvPicPr>
+        <p:blipFill>
+          <a:blip r:embed="rId4">
+            <a:duotone>
+              <a:schemeClr val="accent1">
+                <a:shade val="45000"/>
+                <a:satMod val="135000"/>
+              </a:schemeClr>
+              <a:prstClr val="white"/>
+            </a:duotone>
+          </a:blip>
+          <a:stretch>
+            <a:fillRect/>
+          </a:stretch>
+        </p:blipFill>
+        <p:spPr>
+          <a:xfrm>
+            <a:off x="4459956" y="2603416"/>
+            <a:ext cx="604757" cy="604757"/>
+          </a:xfrm>
+          <a:prstGeom prst="rect">
+            <a:avLst/>
+          </a:prstGeom>
+        </p:spPr>
+      </p:pic>
+      <p:pic>
+        <p:nvPicPr>
+          <p:cNvPr id="113" name="Picture 112">
+            <a:extLst>
+              <a:ext uri="{FF2B5EF4-FFF2-40B4-BE49-F238E27FC236}">
+                <a16:creationId xmlns:a16="http://schemas.microsoft.com/office/drawing/2014/main" id="{3D48242F-0B9E-A27A-6480-BBB1566D4253}"/>
+              </a:ext>
+            </a:extLst>
+          </p:cNvPr>
+          <p:cNvPicPr>
+            <a:picLocks noChangeAspect="1"/>
+          </p:cNvPicPr>
+          <p:nvPr/>
+        </p:nvPicPr>
+        <p:blipFill>
+          <a:blip r:embed="rId5">
+            <a:duotone>
+              <a:schemeClr val="accent1">
+                <a:shade val="45000"/>
+                <a:satMod val="135000"/>
+              </a:schemeClr>
+              <a:prstClr val="white"/>
+            </a:duotone>
+          </a:blip>
+          <a:stretch>
+            <a:fillRect/>
+          </a:stretch>
+        </p:blipFill>
+        <p:spPr>
+          <a:xfrm>
+            <a:off x="4931008" y="2603416"/>
+            <a:ext cx="604757" cy="604757"/>
+          </a:xfrm>
+          <a:prstGeom prst="rect">
+            <a:avLst/>
+          </a:prstGeom>
+        </p:spPr>
+      </p:pic>
+      <p:pic>
+        <p:nvPicPr>
+          <p:cNvPr id="115" name="Picture 114" descr="Happy Laugh Woman Icon in SVG, PNG formats">
+            <a:extLst>
+              <a:ext uri="{FF2B5EF4-FFF2-40B4-BE49-F238E27FC236}">
+                <a16:creationId xmlns:a16="http://schemas.microsoft.com/office/drawing/2014/main" id="{1118DC90-E8F4-6D9D-FDB7-465A1683437C}"/>
+              </a:ext>
+            </a:extLst>
+          </p:cNvPr>
+          <p:cNvPicPr>
+            <a:picLocks noChangeAspect="1"/>
+          </p:cNvPicPr>
+          <p:nvPr/>
+        </p:nvPicPr>
+        <p:blipFill>
+          <a:blip r:embed="rId4">
+            <a:duotone>
+              <a:schemeClr val="accent1">
+                <a:shade val="45000"/>
+                <a:satMod val="135000"/>
+              </a:schemeClr>
+              <a:prstClr val="white"/>
+            </a:duotone>
+          </a:blip>
+          <a:stretch>
+            <a:fillRect/>
+          </a:stretch>
+        </p:blipFill>
+        <p:spPr>
+          <a:xfrm>
+            <a:off x="5390208" y="2603416"/>
+            <a:ext cx="604757" cy="604757"/>
+          </a:xfrm>
+          <a:prstGeom prst="rect">
+            <a:avLst/>
+          </a:prstGeom>
+        </p:spPr>
+      </p:pic>
+      <p:pic>
+        <p:nvPicPr>
+          <p:cNvPr id="123" name="Picture 122" descr="Happy Laugh Woman Icon in SVG, PNG formats">
+            <a:extLst>
+              <a:ext uri="{FF2B5EF4-FFF2-40B4-BE49-F238E27FC236}">
+                <a16:creationId xmlns:a16="http://schemas.microsoft.com/office/drawing/2014/main" id="{BD353239-7B92-D128-EF3A-FB8359E1B461}"/>
+              </a:ext>
+            </a:extLst>
+          </p:cNvPr>
+          <p:cNvPicPr>
+            <a:picLocks noChangeAspect="1"/>
+          </p:cNvPicPr>
+          <p:nvPr/>
+        </p:nvPicPr>
+        <p:blipFill>
+          <a:blip r:embed="rId4">
+            <a:duotone>
+              <a:schemeClr val="accent1">
+                <a:shade val="45000"/>
+                <a:satMod val="135000"/>
+              </a:schemeClr>
+              <a:prstClr val="white"/>
+            </a:duotone>
+          </a:blip>
+          <a:stretch>
+            <a:fillRect/>
+          </a:stretch>
+        </p:blipFill>
+        <p:spPr>
+          <a:xfrm>
+            <a:off x="8977224" y="789145"/>
+            <a:ext cx="604757" cy="604757"/>
+          </a:xfrm>
+          <a:prstGeom prst="rect">
+            <a:avLst/>
+          </a:prstGeom>
+        </p:spPr>
+      </p:pic>
+      <p:pic>
+        <p:nvPicPr>
+          <p:cNvPr id="125" name="Picture 124">
+            <a:extLst>
+              <a:ext uri="{FF2B5EF4-FFF2-40B4-BE49-F238E27FC236}">
+                <a16:creationId xmlns:a16="http://schemas.microsoft.com/office/drawing/2014/main" id="{8F2B4D9C-57C9-D097-7D93-D6C32825D433}"/>
+              </a:ext>
+            </a:extLst>
+          </p:cNvPr>
+          <p:cNvPicPr>
+            <a:picLocks noChangeAspect="1"/>
+          </p:cNvPicPr>
+          <p:nvPr/>
+        </p:nvPicPr>
+        <p:blipFill>
+          <a:blip r:embed="rId5">
+            <a:duotone>
+              <a:schemeClr val="accent1">
+                <a:shade val="45000"/>
+                <a:satMod val="135000"/>
+              </a:schemeClr>
+              <a:prstClr val="white"/>
+            </a:duotone>
+          </a:blip>
+          <a:stretch>
+            <a:fillRect/>
+          </a:stretch>
+        </p:blipFill>
+        <p:spPr>
+          <a:xfrm>
+            <a:off x="9448276" y="789145"/>
+            <a:ext cx="604757" cy="604757"/>
+          </a:xfrm>
+          <a:prstGeom prst="rect">
+            <a:avLst/>
+          </a:prstGeom>
+        </p:spPr>
+      </p:pic>
+      <p:pic>
+        <p:nvPicPr>
+          <p:cNvPr id="127" name="Picture 126" descr="Happy Laugh Woman Icon in SVG, PNG formats">
+            <a:extLst>
+              <a:ext uri="{FF2B5EF4-FFF2-40B4-BE49-F238E27FC236}">
+                <a16:creationId xmlns:a16="http://schemas.microsoft.com/office/drawing/2014/main" id="{BB2D62FB-3E60-FFED-E72B-88A091C349BF}"/>
+              </a:ext>
+            </a:extLst>
+          </p:cNvPr>
+          <p:cNvPicPr>
+            <a:picLocks noChangeAspect="1"/>
+          </p:cNvPicPr>
+          <p:nvPr/>
+        </p:nvPicPr>
+        <p:blipFill>
+          <a:blip r:embed="rId4">
+            <a:duotone>
+              <a:schemeClr val="accent1">
+                <a:shade val="45000"/>
+                <a:satMod val="135000"/>
+              </a:schemeClr>
+              <a:prstClr val="white"/>
+            </a:duotone>
+          </a:blip>
+          <a:stretch>
+            <a:fillRect/>
+          </a:stretch>
+        </p:blipFill>
+        <p:spPr>
+          <a:xfrm>
+            <a:off x="9907476" y="789145"/>
+            <a:ext cx="604757" cy="604757"/>
+          </a:xfrm>
+          <a:prstGeom prst="rect">
+            <a:avLst/>
+          </a:prstGeom>
+        </p:spPr>
+      </p:pic>
+      <p:pic>
+        <p:nvPicPr>
+          <p:cNvPr id="129" name="Picture 128">
+            <a:extLst>
+              <a:ext uri="{FF2B5EF4-FFF2-40B4-BE49-F238E27FC236}">
+                <a16:creationId xmlns:a16="http://schemas.microsoft.com/office/drawing/2014/main" id="{479D094F-2EB6-2AF7-82EA-3BE0F4728C02}"/>
+              </a:ext>
+            </a:extLst>
+          </p:cNvPr>
+          <p:cNvPicPr>
+            <a:picLocks noChangeAspect="1"/>
+          </p:cNvPicPr>
+          <p:nvPr/>
+        </p:nvPicPr>
+        <p:blipFill>
+          <a:blip r:embed="rId5">
+            <a:duotone>
+              <a:schemeClr val="accent1">
+                <a:shade val="45000"/>
+                <a:satMod val="135000"/>
+              </a:schemeClr>
+              <a:prstClr val="white"/>
+            </a:duotone>
+          </a:blip>
+          <a:stretch>
+            <a:fillRect/>
+          </a:stretch>
+        </p:blipFill>
+        <p:spPr>
+          <a:xfrm>
+            <a:off x="10378528" y="789145"/>
+            <a:ext cx="604757" cy="604757"/>
+          </a:xfrm>
+          <a:prstGeom prst="rect">
+            <a:avLst/>
+          </a:prstGeom>
+        </p:spPr>
+      </p:pic>
+      <p:pic>
+        <p:nvPicPr>
+          <p:cNvPr id="133" name="Picture 132">
+            <a:extLst>
+              <a:ext uri="{FF2B5EF4-FFF2-40B4-BE49-F238E27FC236}">
+                <a16:creationId xmlns:a16="http://schemas.microsoft.com/office/drawing/2014/main" id="{56ED56DC-5C64-3F83-CFB8-C224DBD6CDDB}"/>
+              </a:ext>
+            </a:extLst>
+          </p:cNvPr>
+          <p:cNvPicPr>
+            <a:picLocks noChangeAspect="1"/>
+          </p:cNvPicPr>
+          <p:nvPr/>
+        </p:nvPicPr>
+        <p:blipFill>
+          <a:blip r:embed="rId5">
+            <a:duotone>
+              <a:schemeClr val="accent1">
+                <a:shade val="45000"/>
+                <a:satMod val="135000"/>
+              </a:schemeClr>
+              <a:prstClr val="white"/>
+            </a:duotone>
+          </a:blip>
+          <a:stretch>
+            <a:fillRect/>
+          </a:stretch>
+        </p:blipFill>
+        <p:spPr>
+          <a:xfrm>
+            <a:off x="8485112" y="789145"/>
+            <a:ext cx="604757" cy="604757"/>
+          </a:xfrm>
+          <a:prstGeom prst="rect">
+            <a:avLst/>
+          </a:prstGeom>
+        </p:spPr>
+      </p:pic>
+      <p:pic>
+        <p:nvPicPr>
+          <p:cNvPr id="135" name="Picture 134">
+            <a:extLst>
+              <a:ext uri="{FF2B5EF4-FFF2-40B4-BE49-F238E27FC236}">
+                <a16:creationId xmlns:a16="http://schemas.microsoft.com/office/drawing/2014/main" id="{76B462E9-EA0E-8681-CAE2-80CAE56642E7}"/>
+              </a:ext>
+            </a:extLst>
+          </p:cNvPr>
+          <p:cNvPicPr>
+            <a:picLocks noChangeAspect="1"/>
+          </p:cNvPicPr>
+          <p:nvPr/>
+        </p:nvPicPr>
+        <p:blipFill>
+          <a:blip r:embed="rId5">
+            <a:duotone>
+              <a:schemeClr val="accent1">
+                <a:shade val="45000"/>
+                <a:satMod val="135000"/>
+              </a:schemeClr>
+              <a:prstClr val="white"/>
+            </a:duotone>
+          </a:blip>
+          <a:stretch>
+            <a:fillRect/>
+          </a:stretch>
+        </p:blipFill>
+        <p:spPr>
+          <a:xfrm>
+            <a:off x="8328290" y="1393902"/>
+            <a:ext cx="604757" cy="604757"/>
+          </a:xfrm>
+          <a:prstGeom prst="rect">
+            <a:avLst/>
+          </a:prstGeom>
+        </p:spPr>
+      </p:pic>
+      <p:pic>
+        <p:nvPicPr>
+          <p:cNvPr id="137" name="Picture 136" descr="Happy Laugh Woman Icon in SVG, PNG formats">
+            <a:extLst>
+              <a:ext uri="{FF2B5EF4-FFF2-40B4-BE49-F238E27FC236}">
+                <a16:creationId xmlns:a16="http://schemas.microsoft.com/office/drawing/2014/main" id="{5F13C39C-CB6F-F733-645D-A170C42ED5D6}"/>
+              </a:ext>
+            </a:extLst>
+          </p:cNvPr>
+          <p:cNvPicPr>
+            <a:picLocks noChangeAspect="1"/>
+          </p:cNvPicPr>
+          <p:nvPr/>
+        </p:nvPicPr>
+        <p:blipFill>
+          <a:blip r:embed="rId4">
+            <a:duotone>
+              <a:schemeClr val="accent1">
+                <a:shade val="45000"/>
+                <a:satMod val="135000"/>
+              </a:schemeClr>
+              <a:prstClr val="white"/>
+            </a:duotone>
+          </a:blip>
+          <a:stretch>
+            <a:fillRect/>
+          </a:stretch>
+        </p:blipFill>
+        <p:spPr>
+          <a:xfrm>
+            <a:off x="8767921" y="1393902"/>
+            <a:ext cx="604757" cy="604757"/>
+          </a:xfrm>
+          <a:prstGeom prst="rect">
+            <a:avLst/>
+          </a:prstGeom>
+        </p:spPr>
+      </p:pic>
+      <p:pic>
+        <p:nvPicPr>
+          <p:cNvPr id="139" name="Picture 138">
+            <a:extLst>
+              <a:ext uri="{FF2B5EF4-FFF2-40B4-BE49-F238E27FC236}">
+                <a16:creationId xmlns:a16="http://schemas.microsoft.com/office/drawing/2014/main" id="{B35BC21B-5893-2F68-8EEB-CA9F917FC511}"/>
+              </a:ext>
+            </a:extLst>
+          </p:cNvPr>
+          <p:cNvPicPr>
+            <a:picLocks noChangeAspect="1"/>
+          </p:cNvPicPr>
+          <p:nvPr/>
+        </p:nvPicPr>
+        <p:blipFill>
+          <a:blip r:embed="rId5">
+            <a:duotone>
+              <a:schemeClr val="accent1">
+                <a:shade val="45000"/>
+                <a:satMod val="135000"/>
+              </a:schemeClr>
+              <a:prstClr val="white"/>
+            </a:duotone>
+          </a:blip>
+          <a:stretch>
+            <a:fillRect/>
+          </a:stretch>
+        </p:blipFill>
+        <p:spPr>
+          <a:xfrm>
+            <a:off x="9238973" y="1393902"/>
+            <a:ext cx="604757" cy="604757"/>
+          </a:xfrm>
+          <a:prstGeom prst="rect">
+            <a:avLst/>
+          </a:prstGeom>
+        </p:spPr>
+      </p:pic>
+      <p:pic>
+        <p:nvPicPr>
+          <p:cNvPr id="141" name="Picture 140" descr="Happy Laugh Woman Icon in SVG, PNG formats">
+            <a:extLst>
+              <a:ext uri="{FF2B5EF4-FFF2-40B4-BE49-F238E27FC236}">
+                <a16:creationId xmlns:a16="http://schemas.microsoft.com/office/drawing/2014/main" id="{F27F407D-F257-92D1-1409-8B22E9E6B3D3}"/>
+              </a:ext>
+            </a:extLst>
+          </p:cNvPr>
+          <p:cNvPicPr>
+            <a:picLocks noChangeAspect="1"/>
+          </p:cNvPicPr>
+          <p:nvPr/>
+        </p:nvPicPr>
+        <p:blipFill>
+          <a:blip r:embed="rId4">
+            <a:duotone>
+              <a:schemeClr val="accent1">
+                <a:shade val="45000"/>
+                <a:satMod val="135000"/>
+              </a:schemeClr>
+              <a:prstClr val="white"/>
+            </a:duotone>
+          </a:blip>
+          <a:stretch>
+            <a:fillRect/>
+          </a:stretch>
+        </p:blipFill>
+        <p:spPr>
+          <a:xfrm>
+            <a:off x="9698173" y="1393902"/>
+            <a:ext cx="604757" cy="604757"/>
+          </a:xfrm>
+          <a:prstGeom prst="rect">
+            <a:avLst/>
+          </a:prstGeom>
+        </p:spPr>
+      </p:pic>
+      <p:pic>
+        <p:nvPicPr>
+          <p:cNvPr id="149" name="Picture 148">
+            <a:extLst>
+              <a:ext uri="{FF2B5EF4-FFF2-40B4-BE49-F238E27FC236}">
+                <a16:creationId xmlns:a16="http://schemas.microsoft.com/office/drawing/2014/main" id="{F13E3B14-73F9-78F3-2F58-67E69B37BB6E}"/>
+              </a:ext>
+            </a:extLst>
+          </p:cNvPr>
+          <p:cNvPicPr>
+            <a:picLocks noChangeAspect="1"/>
+          </p:cNvPicPr>
+          <p:nvPr/>
+        </p:nvPicPr>
+        <p:blipFill>
+          <a:blip r:embed="rId5">
+            <a:duotone>
+              <a:schemeClr val="accent1">
+                <a:shade val="45000"/>
+                <a:satMod val="135000"/>
+              </a:schemeClr>
+              <a:prstClr val="white"/>
+            </a:duotone>
+          </a:blip>
+          <a:stretch>
+            <a:fillRect/>
+          </a:stretch>
+        </p:blipFill>
+        <p:spPr>
+          <a:xfrm>
+            <a:off x="8630668" y="1998659"/>
+            <a:ext cx="604757" cy="604757"/>
+          </a:xfrm>
+          <a:prstGeom prst="rect">
+            <a:avLst/>
+          </a:prstGeom>
+        </p:spPr>
+      </p:pic>
+      <p:pic>
+        <p:nvPicPr>
+          <p:cNvPr id="151" name="Picture 150" descr="Happy Laugh Woman Icon in SVG, PNG formats">
+            <a:extLst>
+              <a:ext uri="{FF2B5EF4-FFF2-40B4-BE49-F238E27FC236}">
+                <a16:creationId xmlns:a16="http://schemas.microsoft.com/office/drawing/2014/main" id="{C1FB5F13-A2B1-D748-CBAE-D351AA047C92}"/>
+              </a:ext>
+            </a:extLst>
+          </p:cNvPr>
+          <p:cNvPicPr>
+            <a:picLocks noChangeAspect="1"/>
+          </p:cNvPicPr>
+          <p:nvPr/>
+        </p:nvPicPr>
+        <p:blipFill>
+          <a:blip r:embed="rId4">
+            <a:duotone>
+              <a:schemeClr val="accent1">
+                <a:shade val="45000"/>
+                <a:satMod val="135000"/>
+              </a:schemeClr>
+              <a:prstClr val="white"/>
+            </a:duotone>
+          </a:blip>
+          <a:stretch>
+            <a:fillRect/>
+          </a:stretch>
+        </p:blipFill>
+        <p:spPr>
+          <a:xfrm>
+            <a:off x="9070299" y="1998659"/>
+            <a:ext cx="604757" cy="604757"/>
+          </a:xfrm>
+          <a:prstGeom prst="rect">
+            <a:avLst/>
+          </a:prstGeom>
+        </p:spPr>
+      </p:pic>
+      <p:pic>
+        <p:nvPicPr>
+          <p:cNvPr id="153" name="Picture 152">
+            <a:extLst>
+              <a:ext uri="{FF2B5EF4-FFF2-40B4-BE49-F238E27FC236}">
+                <a16:creationId xmlns:a16="http://schemas.microsoft.com/office/drawing/2014/main" id="{CEE0FACC-70C4-30C4-6247-626EFC0577EC}"/>
+              </a:ext>
+            </a:extLst>
+          </p:cNvPr>
+          <p:cNvPicPr>
+            <a:picLocks noChangeAspect="1"/>
+          </p:cNvPicPr>
+          <p:nvPr/>
+        </p:nvPicPr>
+        <p:blipFill>
+          <a:blip r:embed="rId5">
+            <a:duotone>
+              <a:schemeClr val="accent1">
+                <a:shade val="45000"/>
+                <a:satMod val="135000"/>
+              </a:schemeClr>
+              <a:prstClr val="white"/>
+            </a:duotone>
+          </a:blip>
+          <a:stretch>
+            <a:fillRect/>
+          </a:stretch>
+        </p:blipFill>
+        <p:spPr>
+          <a:xfrm>
+            <a:off x="9541351" y="1998659"/>
+            <a:ext cx="604757" cy="604757"/>
+          </a:xfrm>
+          <a:prstGeom prst="rect">
+            <a:avLst/>
+          </a:prstGeom>
+        </p:spPr>
+      </p:pic>
+      <p:pic>
+        <p:nvPicPr>
+          <p:cNvPr id="161" name="Picture 160" descr="Happy Laugh Woman Icon in SVG, PNG formats">
+            <a:extLst>
+              <a:ext uri="{FF2B5EF4-FFF2-40B4-BE49-F238E27FC236}">
+                <a16:creationId xmlns:a16="http://schemas.microsoft.com/office/drawing/2014/main" id="{E98EE715-BCBA-81AC-21FA-7CD4FE0973F6}"/>
+              </a:ext>
+            </a:extLst>
+          </p:cNvPr>
+          <p:cNvPicPr>
+            <a:picLocks noChangeAspect="1"/>
+          </p:cNvPicPr>
+          <p:nvPr/>
+        </p:nvPicPr>
+        <p:blipFill>
+          <a:blip r:embed="rId4">
+            <a:duotone>
+              <a:schemeClr val="accent1">
+                <a:shade val="45000"/>
+                <a:satMod val="135000"/>
+              </a:schemeClr>
+              <a:prstClr val="white"/>
+            </a:duotone>
+          </a:blip>
+          <a:stretch>
+            <a:fillRect/>
+          </a:stretch>
+        </p:blipFill>
+        <p:spPr>
+          <a:xfrm>
+            <a:off x="8372467" y="2603416"/>
+            <a:ext cx="604757" cy="604757"/>
+          </a:xfrm>
+          <a:prstGeom prst="rect">
+            <a:avLst/>
+          </a:prstGeom>
+        </p:spPr>
+      </p:pic>
+      <p:pic>
+        <p:nvPicPr>
+          <p:cNvPr id="163" name="Picture 162">
+            <a:extLst>
+              <a:ext uri="{FF2B5EF4-FFF2-40B4-BE49-F238E27FC236}">
+                <a16:creationId xmlns:a16="http://schemas.microsoft.com/office/drawing/2014/main" id="{CD1CEB6D-63E5-8A79-3C46-67CD737F24BC}"/>
+              </a:ext>
+            </a:extLst>
+          </p:cNvPr>
+          <p:cNvPicPr>
+            <a:picLocks noChangeAspect="1"/>
+          </p:cNvPicPr>
+          <p:nvPr/>
+        </p:nvPicPr>
+        <p:blipFill>
+          <a:blip r:embed="rId5">
+            <a:duotone>
+              <a:schemeClr val="accent1">
+                <a:shade val="45000"/>
+                <a:satMod val="135000"/>
+              </a:schemeClr>
+              <a:prstClr val="white"/>
+            </a:duotone>
+          </a:blip>
+          <a:stretch>
+            <a:fillRect/>
+          </a:stretch>
+        </p:blipFill>
+        <p:spPr>
+          <a:xfrm>
+            <a:off x="8843519" y="2603416"/>
+            <a:ext cx="604757" cy="604757"/>
+          </a:xfrm>
+          <a:prstGeom prst="rect">
+            <a:avLst/>
+          </a:prstGeom>
+        </p:spPr>
+      </p:pic>
+      <p:pic>
+        <p:nvPicPr>
+          <p:cNvPr id="165" name="Picture 164" descr="Happy Laugh Woman Icon in SVG, PNG formats">
+            <a:extLst>
+              <a:ext uri="{FF2B5EF4-FFF2-40B4-BE49-F238E27FC236}">
+                <a16:creationId xmlns:a16="http://schemas.microsoft.com/office/drawing/2014/main" id="{79FF0533-AEE4-63D4-4F0F-01D29742B330}"/>
+              </a:ext>
+            </a:extLst>
+          </p:cNvPr>
+          <p:cNvPicPr>
+            <a:picLocks noChangeAspect="1"/>
+          </p:cNvPicPr>
+          <p:nvPr/>
+        </p:nvPicPr>
+        <p:blipFill>
+          <a:blip r:embed="rId4">
+            <a:duotone>
+              <a:schemeClr val="accent1">
+                <a:shade val="45000"/>
+                <a:satMod val="135000"/>
+              </a:schemeClr>
+              <a:prstClr val="white"/>
+            </a:duotone>
+          </a:blip>
+          <a:stretch>
+            <a:fillRect/>
+          </a:stretch>
+        </p:blipFill>
+        <p:spPr>
+          <a:xfrm>
+            <a:off x="9302719" y="2603416"/>
+            <a:ext cx="604757" cy="604757"/>
+          </a:xfrm>
+          <a:prstGeom prst="rect">
+            <a:avLst/>
+          </a:prstGeom>
+        </p:spPr>
+      </p:pic>
+    </p:spTree>
+    <p:extLst>
+      <p:ext uri="{BB962C8B-B14F-4D97-AF65-F5344CB8AC3E}">
+        <p14:creationId xmlns:p14="http://schemas.microsoft.com/office/powerpoint/2010/main" val="107539152"/>
+      </p:ext>
+    </p:extLst>
+  </p:cSld>
+  <p:clrMapOvr>
+    <a:masterClrMapping/>
+  </p:clrMapOvr>
+</p:sld>
+</file>
+
 <file path=ppt/theme/theme1.xml><?xml version="1.0" encoding="utf-8"?>
 <a:theme xmlns:a="http://schemas.openxmlformats.org/drawingml/2006/main" name="Office Theme">
   <a:themeElements>

</xml_diff>